<commit_message>
docs: finalize jury passport research and presentation for v3
</commit_message>
<xml_diff>
--- a/docs/presentation/FireWatch_КосмоХакатон_2026.pptx
+++ b/docs/presentation/FireWatch_КосмоХакатон_2026.pptx
@@ -2,22 +2,22 @@
 <file path=ppt/presentation.xml><?xml version="1.0" encoding="utf-8"?>
 <p:presentation xmlns:p="http://schemas.openxmlformats.org/presentationml/2006/main">
   <p:sldMasterIdLst>
-    <p:sldMasterId xmlns:r="http://schemas.openxmlformats.org/officeDocument/2006/relationships" id="2147483648" r:id="Ra5aae9f160ba4fa1"/>
+    <p:sldMasterId xmlns:r="http://schemas.openxmlformats.org/officeDocument/2006/relationships" id="2147483648" r:id="Rf659604097274fd9"/>
   </p:sldMasterIdLst>
   <p:notesMasterIdLst>
-    <p:notesMasterId xmlns:r="http://schemas.openxmlformats.org/officeDocument/2006/relationships" r:id="Ra8e66c85f9b34341"/>
+    <p:notesMasterId xmlns:r="http://schemas.openxmlformats.org/officeDocument/2006/relationships" r:id="R23cb84ca122b4ffa"/>
   </p:notesMasterIdLst>
   <p:sldIdLst>
-    <p:sldId xmlns:r="http://schemas.openxmlformats.org/officeDocument/2006/relationships" id="256" r:id="Rffa2f0798cc349d7"/>
-    <p:sldId xmlns:r="http://schemas.openxmlformats.org/officeDocument/2006/relationships" id="257" r:id="R101a071759424e7e"/>
-    <p:sldId xmlns:r="http://schemas.openxmlformats.org/officeDocument/2006/relationships" id="258" r:id="R84678c360b0e4a86"/>
-    <p:sldId xmlns:r="http://schemas.openxmlformats.org/officeDocument/2006/relationships" id="259" r:id="Rce12af8eb3ac4a84"/>
-    <p:sldId xmlns:r="http://schemas.openxmlformats.org/officeDocument/2006/relationships" id="260" r:id="R23fca47e4d9d4b6f"/>
-    <p:sldId xmlns:r="http://schemas.openxmlformats.org/officeDocument/2006/relationships" id="261" r:id="R26cfcb05525b44c2"/>
-    <p:sldId xmlns:r="http://schemas.openxmlformats.org/officeDocument/2006/relationships" id="262" r:id="R5b2b5d33e80b4fb9"/>
-    <p:sldId xmlns:r="http://schemas.openxmlformats.org/officeDocument/2006/relationships" id="263" r:id="Re11adfc0ec674d21"/>
-    <p:sldId xmlns:r="http://schemas.openxmlformats.org/officeDocument/2006/relationships" id="264" r:id="R0111b90d6d144eb2"/>
-    <p:sldId xmlns:r="http://schemas.openxmlformats.org/officeDocument/2006/relationships" id="265" r:id="R70c4929eefdd4e2d"/>
+    <p:sldId xmlns:r="http://schemas.openxmlformats.org/officeDocument/2006/relationships" id="256" r:id="R601541d2361a4b59"/>
+    <p:sldId xmlns:r="http://schemas.openxmlformats.org/officeDocument/2006/relationships" id="257" r:id="Rbbcb3499280a4fa7"/>
+    <p:sldId xmlns:r="http://schemas.openxmlformats.org/officeDocument/2006/relationships" id="258" r:id="Rb3fa7b0f7e414a21"/>
+    <p:sldId xmlns:r="http://schemas.openxmlformats.org/officeDocument/2006/relationships" id="259" r:id="R7a060b04a54e4a16"/>
+    <p:sldId xmlns:r="http://schemas.openxmlformats.org/officeDocument/2006/relationships" id="260" r:id="R7b2dab66c172416d"/>
+    <p:sldId xmlns:r="http://schemas.openxmlformats.org/officeDocument/2006/relationships" id="261" r:id="R28d8ba8ed8994283"/>
+    <p:sldId xmlns:r="http://schemas.openxmlformats.org/officeDocument/2006/relationships" id="262" r:id="R2258d937a3b34780"/>
+    <p:sldId xmlns:r="http://schemas.openxmlformats.org/officeDocument/2006/relationships" id="263" r:id="R2c7e6624f63349d6"/>
+    <p:sldId xmlns:r="http://schemas.openxmlformats.org/officeDocument/2006/relationships" id="264" r:id="R4f6d2f2b9dc840e9"/>
+    <p:sldId xmlns:r="http://schemas.openxmlformats.org/officeDocument/2006/relationships" id="265" r:id="R1e3211bdc9d3471c"/>
   </p:sldIdLst>
   <p:sldSz cx="12192000" cy="6858000"/>
   <p:notesSz cx="6858000" cy="9144000"/>
@@ -521,7 +521,7 @@
           <a:lstStyle xmlns:a="http://schemas.openxmlformats.org/drawingml/2006/main"/>
           <a:p xmlns:a="http://schemas.openxmlformats.org/drawingml/2006/main">
             <a:r>
-              <a:t>Команда: 4_th_try. Источник: README.md, «Данные и границы применения»; docs/evaluation.md, «Готовность релизного кандидата»; CHANGELOG.md. Публичный E2E, rollback и parity CPU Windows/Linux на 4 сценах: PASS. Основной конкурсный репозиторий: https://gitverse.ru/hackrus.experts/kosmo-krasnoiarsk_4_th_try_106. Зеркало разработки: https://github.com/foxxed20-ux/firewatch.</a:t>
+              <a:t>Команда: 4_th_try. Источник: README.md, «Данные и границы применения»; docs/evaluation.md, «Готовность релизного кандидата»; CHANGELOG.md. V3 service: public E2E 91 HTTP checks / 6 jobs, browser BS/export, rollback V3→V2 на реальном BS159 и восстановление V3, parity raw mask CPU Windows/Linux на 4 сценах: PASS. Проверка hole polygon: 644 features, 616,281 га: PASS. Full V3 CLI 269/447 завершён за 390.703092179 с на GPU T4/CUDA; CPU replay 129: Δ=0 во всех трёх checks. artifacts/ensemble-v3/evidence/submission_validation.json: EXIT 0, 447 data rows, exact order, canonical RLE, BS exclusivity, SHA-256 d5ba983965a146a68195bae8a38d7e53ae21fdefdf3709aade977f4eccfb739c. Основной конкурсный репозиторий: https://gitverse.ru/hackrus.experts/kosmo-krasnoiarsk_4_th_try_106. Зеркало разработки: https://github.com/foxxed20-ux/firewatch.</a:t>
             </a:r>
           </a:p>
         </p:txBody>
@@ -941,7 +941,7 @@
           <a:lstStyle xmlns:a="http://schemas.openxmlformats.org/drawingml/2006/main"/>
           <a:p xmlns:a="http://schemas.openxmlformats.org/drawingml/2006/main">
             <a:r>
-              <a:t>Источник: artifacts/ensemble-v2/selected_recipes.json; artifacts/tree-v1/tuned_recipes.json; artifacts/cnn-v1/af/validation_report.json; artifacts/ensemble-v2/demo_smoke/report.json. dNBR comparator: burnIoU 0.3638147045, mIoUsev 0.3542668560, пороги 0.1/0.2/0.4. CPU replay v2 на 129 validation-чипах: PASS. Это validation, не закрытый test Score.</a:t>
+              <a:t>V3 candidate: AF F1 0.9295086969789441; BS ensemble 25% CNN / 75% LightGBM, multipliers [1, 2.2, 2.2, 1.3]: burnIoU 0.586688701444679, mIoU severity 0.5883615062423446, Score 0.7071775413209715. V3 vs V2: +0.00446196389 Score; bootstrap 95% [−0.00139005, +0.01121531], интервал включает 0, результат условен на selected recipes. dNBR comparator: burnIoU 0.3638147045, mIoUsev 0.3542668560, пороги 0.1/0.2/0.4. Full V3 CLI: 269 чипов, 447 строк, 390.703092179 с на GPU T4/CUDA; CPU replay 129 (84 AF / 45 BS): Δ=0 во всех трёх checks. Independent CSV validator: EXIT 0, 447 data rows, exact order, canonical RLE и BS exclusivity; SHA-256 d5ba983965a146a68195bae8a38d7e53ae21fdefdf3709aade977f4eccfb739c. Это validation, не закрытый test Score.</a:t>
             </a:r>
           </a:p>
         </p:txBody>
@@ -1011,7 +1011,7 @@
           <a:lstStyle xmlns:a="http://schemas.openxmlformats.org/drawingml/2006/main"/>
           <a:p xmlns:a="http://schemas.openxmlformats.org/drawingml/2006/main">
             <a:r>
-              <a:t>Источник: docs/assets/firewatch-bs-demo.png, копия artifacts/frontend/public-bs-desktop.png. Проверенный публичный HTTPS capture: official-ensemble-v2, BS_tr_000159, 938,5 га, coverage 25,4%; severity 242,9 / 176,4 / 519,1 га. Public BS GeoJSON download: PASS. Демо на train/validation, не закрытый test. Также: README.md, «Демонстрация»; docs/architecture.md, «Запрос на анализ»; docs/evaluation.md.</a:t>
+              <a:t>Источник: docs/assets/firewatch-bs-demo.png, копия artifacts/frontend/v3-bs-desktop.png. Проверенный публичный HTTPS capture: release 20260919-ensemble-4, bundle official-ensemble-v3, BS_tr_000159, 1 037,3 га, coverage 25,4%, 1 171 полигон; severity 250,6 / 178,8 / 607,9 га. Browser BS и export: PASS. Демо на train/validation, не закрытый test. Также: README.md, «Демонстрация»; docs/architecture.md, «Запрос на анализ»; docs/evaluation.md.</a:t>
             </a:r>
           </a:p>
         </p:txBody>
@@ -1081,7 +1081,7 @@
           <a:lstStyle xmlns:a="http://schemas.openxmlformats.org/drawingml/2006/main"/>
           <a:p xmlns:a="http://schemas.openxmlformats.org/drawingml/2006/main">
             <a:r>
-              <a:t>Источник: подтверждённый полный offline CLI-прогон v2 владельца model runtime: 269 чипов, 447 строк, 540,3043 с, сеть заблокирована. CPU replay всех 129 validation-чипов: PASS. Также: README.md, «Почему решение можно проверить» и «Проверки»; docs/evaluation.md, таблица «Что подтверждает каждый вид проверки». Время относится к среде команды, не к организаторскому speed score.</a:t>
+              <a:t>Источник: завершённый full V3 CLI владельца model runtime: 269 чипов, 447 строк, 390.703092179 с на GPU T4/CUDA. CPU replay 129 validation-чипов (84 AF / 45 BS): Δ=0 во всех трёх checks; обучение завершено. artifacts/ensemble-v3/evidence/submission_validation.json: EXIT 0, SHA-256 d5ba983965a146a68195bae8a38d7e53ae21fdefdf3709aade977f4eccfb739c; 447 data rows, exact order, canonical RLE, BS exclusivity. Также: README.md, «Почему решение можно проверить» и «Проверки»; docs/evaluation.md, таблица «Что подтверждает каждый вид проверки». Время относится к среде команды, не к организаторскому speed score.</a:t>
             </a:r>
           </a:p>
         </p:txBody>
@@ -1149,7 +1149,7 @@
   </p:cSld>
   <p:clrMap bg1="lt1" tx1="dk1" bg2="lt2" tx2="dk2" accent1="accent1" accent2="accent2" accent3="accent3" accent4="accent4" accent5="accent5" accent6="accent6" hlink="hlink" folHlink="folHlink"/>
   <p:sldLayoutIdLst>
-    <p:sldLayoutId xmlns:r="http://schemas.openxmlformats.org/officeDocument/2006/relationships" id="2147483649" r:id="R09cff8377c224b71"/>
+    <p:sldLayoutId xmlns:r="http://schemas.openxmlformats.org/officeDocument/2006/relationships" id="2147483649" r:id="Ra71774b36f094ac2"/>
   </p:sldLayoutIdLst>
   <p:txStyles>
     <p:titleStyle>
@@ -1717,10 +1717,10 @@
                 <c:formatCode>General</c:formatCode>
                 <c:ptCount val="2"/>
                 <c:pt idx="0">
-                  <c:v>0.3638147045</c:v>
+                  <c:v>0.363815</c:v>
                 </c:pt>
                 <c:pt idx="1">
-                  <c:v>0.354266856</c:v>
+                  <c:v>0.354267</c:v>
                 </c:pt>
               </c:numCache>
             </c:numRef>
@@ -1730,7 +1730,7 @@
           <c:idx val="1"/>
           <c:order val="1"/>
           <c:tx>
-            <c:v>Tuned LightGBM</c:v>
+            <c:v>V3 BS ensemble</c:v>
           </c:tx>
           <c:spPr>
             <a:solidFill xmlns:a="http://schemas.openxmlformats.org/drawingml/2006/main">
@@ -1758,10 +1758,10 @@
                 <c:formatCode>General</c:formatCode>
                 <c:ptCount val="2"/>
                 <c:pt idx="0">
-                  <c:v>0.57675420823</c:v>
+                  <c:v>0.586689</c:v>
                 </c:pt>
                 <c:pt idx="1">
-                  <c:v>0.58507853536</c:v>
+                  <c:v>0.588362</c:v>
                 </c:pt>
               </c:numCache>
             </c:numRef>
@@ -1950,10 +1950,10 @@
           <p:nvPr/>
         </p:nvPicPr>
         <p:blipFill>
-          <a:blip xmlns:r="http://schemas.openxmlformats.org/officeDocument/2006/relationships" xmlns:a="http://schemas.openxmlformats.org/drawingml/2006/main" r:embed="Rcf8c1caf34114afb">
+          <a:blip xmlns:r="http://schemas.openxmlformats.org/officeDocument/2006/relationships" xmlns:a="http://schemas.openxmlformats.org/drawingml/2006/main" r:embed="Rf42bef71ead04954">
             <a:extLst>
               <a:ext uri="{96DAC541-7B7A-43D3-8B79-37D633B846F1}">
-                <asvg:svgBlip xmlns:asvg="http://schemas.microsoft.com/office/drawing/2016/SVG/main" r:embed="Rcbe89fb029b24fe0"/>
+                <asvg:svgBlip xmlns:asvg="http://schemas.microsoft.com/office/drawing/2016/SVG/main" r:embed="Rb6d358c054e642ed"/>
               </a:ext>
             </a:extLst>
           </a:blip>
@@ -1974,7 +1974,7 @@
           <p:cNvPr id="2" name="">
             <a:extLst xmlns:a="http://schemas.openxmlformats.org/drawingml/2006/main">
               <a:ext uri="{FF2B5EF4-FFF2-40B4-BE49-F238E27FC236}">
-                <a16:creationId xmlns:a16="http://schemas.microsoft.com/office/drawing/2014/main" id="{C158797A-0677-4BB4-9EB7-EB4EF7180BA1}"/>
+                <a16:creationId xmlns:a16="http://schemas.microsoft.com/office/drawing/2014/main" id="{E09B862F-A155-4990-A75C-92D8E2009B4B}"/>
               </a:ext>
             </a:extLst>
           </p:cNvPr>
@@ -2054,7 +2054,7 @@
           <p:cNvPr id="3" name="">
             <a:extLst xmlns:a="http://schemas.openxmlformats.org/drawingml/2006/main">
               <a:ext uri="{FF2B5EF4-FFF2-40B4-BE49-F238E27FC236}">
-                <a16:creationId xmlns:a16="http://schemas.microsoft.com/office/drawing/2014/main" id="{8EA18497-0021-4E3C-87D0-41BD95C85384}"/>
+                <a16:creationId xmlns:a16="http://schemas.microsoft.com/office/drawing/2014/main" id="{DF266F6C-BF6F-473B-822A-597737C30505}"/>
               </a:ext>
             </a:extLst>
           </p:cNvPr>
@@ -2111,7 +2111,7 @@
           <p:cNvPr id="4" name="">
             <a:extLst xmlns:a="http://schemas.openxmlformats.org/drawingml/2006/main">
               <a:ext uri="{FF2B5EF4-FFF2-40B4-BE49-F238E27FC236}">
-                <a16:creationId xmlns:a16="http://schemas.microsoft.com/office/drawing/2014/main" id="{E1446061-ED20-41B4-9919-A2D49478073B}"/>
+                <a16:creationId xmlns:a16="http://schemas.microsoft.com/office/drawing/2014/main" id="{6372B1CC-A661-4122-9129-D555689BDB50}"/>
               </a:ext>
             </a:extLst>
           </p:cNvPr>
@@ -2166,7 +2166,7 @@
     </p:spTree>
     <p:extLst>
       <p:ext uri="{BB962C8B-B14F-4D97-AF65-F5344CB8AC3E}">
-        <p14:creationId xmlns:p14="http://schemas.microsoft.com/office/powerpoint/2010/main" val="406658216"/>
+        <p14:creationId xmlns:p14="http://schemas.microsoft.com/office/powerpoint/2010/main" val="1558890606"/>
       </p:ext>
     </p:extLst>
   </p:cSld>
@@ -2197,7 +2197,7 @@
           <p:cNvPr id="15" name="">
             <a:extLst xmlns:a="http://schemas.openxmlformats.org/drawingml/2006/main">
               <a:ext uri="{FF2B5EF4-FFF2-40B4-BE49-F238E27FC236}">
-                <a16:creationId xmlns:a16="http://schemas.microsoft.com/office/drawing/2014/main" id="{F91B9B1F-B0A4-4DAA-9E51-E6AE32A491D9}"/>
+                <a16:creationId xmlns:a16="http://schemas.microsoft.com/office/drawing/2014/main" id="{DA825E4F-649E-4C21-A6A7-4B06CEF12006}"/>
               </a:ext>
             </a:extLst>
           </p:cNvPr>
@@ -2229,7 +2229,7 @@
           <p:cNvPr id="2" name="">
             <a:extLst xmlns:a="http://schemas.openxmlformats.org/drawingml/2006/main">
               <a:ext uri="{FF2B5EF4-FFF2-40B4-BE49-F238E27FC236}">
-                <a16:creationId xmlns:a16="http://schemas.microsoft.com/office/drawing/2014/main" id="{D9D33D9A-DF57-4FD4-8968-CE8AC0BE7B35}"/>
+                <a16:creationId xmlns:a16="http://schemas.microsoft.com/office/drawing/2014/main" id="{16D97B4B-A471-4763-A393-915ECECAAC19}"/>
               </a:ext>
             </a:extLst>
           </p:cNvPr>
@@ -2286,7 +2286,7 @@
           <p:cNvPr id="3" name="">
             <a:extLst xmlns:a="http://schemas.openxmlformats.org/drawingml/2006/main">
               <a:ext uri="{FF2B5EF4-FFF2-40B4-BE49-F238E27FC236}">
-                <a16:creationId xmlns:a16="http://schemas.microsoft.com/office/drawing/2014/main" id="{6E0552AC-9C57-4DE2-99FA-AEEF1E923B7E}"/>
+                <a16:creationId xmlns:a16="http://schemas.microsoft.com/office/drawing/2014/main" id="{4CD4B706-26AD-4EF6-9805-D984FA62D49A}"/>
               </a:ext>
             </a:extLst>
           </p:cNvPr>
@@ -2343,7 +2343,7 @@
           <p:cNvPr id="4" name="">
             <a:extLst xmlns:a="http://schemas.openxmlformats.org/drawingml/2006/main">
               <a:ext uri="{FF2B5EF4-FFF2-40B4-BE49-F238E27FC236}">
-                <a16:creationId xmlns:a16="http://schemas.microsoft.com/office/drawing/2014/main" id="{9B36A309-7D24-4843-BA76-67DCBC34527F}"/>
+                <a16:creationId xmlns:a16="http://schemas.microsoft.com/office/drawing/2014/main" id="{FD5A4DCC-FE06-4D4C-83C8-EA1C1EE04B0D}"/>
               </a:ext>
             </a:extLst>
           </p:cNvPr>
@@ -2375,7 +2375,7 @@
           <p:cNvPr id="5" name="">
             <a:extLst xmlns:a="http://schemas.openxmlformats.org/drawingml/2006/main">
               <a:ext uri="{FF2B5EF4-FFF2-40B4-BE49-F238E27FC236}">
-                <a16:creationId xmlns:a16="http://schemas.microsoft.com/office/drawing/2014/main" id="{719D9276-7AE7-488B-90D2-2A1458FEC950}"/>
+                <a16:creationId xmlns:a16="http://schemas.microsoft.com/office/drawing/2014/main" id="{D7040B6B-9F8C-4B68-AC5C-79030091599C}"/>
               </a:ext>
             </a:extLst>
           </p:cNvPr>
@@ -2432,7 +2432,7 @@
           <p:cNvPr id="6" name="">
             <a:extLst xmlns:a="http://schemas.openxmlformats.org/drawingml/2006/main">
               <a:ext uri="{FF2B5EF4-FFF2-40B4-BE49-F238E27FC236}">
-                <a16:creationId xmlns:a16="http://schemas.microsoft.com/office/drawing/2014/main" id="{74096602-0C08-4577-B847-A84070EC468A}"/>
+                <a16:creationId xmlns:a16="http://schemas.microsoft.com/office/drawing/2014/main" id="{8CBEF6A0-4875-41A6-B059-B1BF8895382A}"/>
               </a:ext>
             </a:extLst>
           </p:cNvPr>
@@ -2581,7 +2581,7 @@
           <p:cNvPr id="7" name="">
             <a:extLst xmlns:a="http://schemas.openxmlformats.org/drawingml/2006/main">
               <a:ext uri="{FF2B5EF4-FFF2-40B4-BE49-F238E27FC236}">
-                <a16:creationId xmlns:a16="http://schemas.microsoft.com/office/drawing/2014/main" id="{3CD5E43A-245C-4450-B9A8-6D7AD65034CB}"/>
+                <a16:creationId xmlns:a16="http://schemas.microsoft.com/office/drawing/2014/main" id="{DBBC9195-1144-4D22-A745-13F6D89A3A39}"/>
               </a:ext>
             </a:extLst>
           </p:cNvPr>
@@ -2613,7 +2613,7 @@
           <p:cNvPr id="8" name="">
             <a:extLst xmlns:a="http://schemas.openxmlformats.org/drawingml/2006/main">
               <a:ext uri="{FF2B5EF4-FFF2-40B4-BE49-F238E27FC236}">
-                <a16:creationId xmlns:a16="http://schemas.microsoft.com/office/drawing/2014/main" id="{C62BFB0E-03C7-4B39-9A58-83507712134C}"/>
+                <a16:creationId xmlns:a16="http://schemas.microsoft.com/office/drawing/2014/main" id="{A7EA0362-3195-4B63-87D3-E141530686A0}"/>
               </a:ext>
             </a:extLst>
           </p:cNvPr>
@@ -2670,7 +2670,7 @@
           <p:cNvPr id="9" name="">
             <a:extLst xmlns:a="http://schemas.openxmlformats.org/drawingml/2006/main">
               <a:ext uri="{FF2B5EF4-FFF2-40B4-BE49-F238E27FC236}">
-                <a16:creationId xmlns:a16="http://schemas.microsoft.com/office/drawing/2014/main" id="{13A9D39B-1420-4572-9DBB-C3B29C623114}"/>
+                <a16:creationId xmlns:a16="http://schemas.microsoft.com/office/drawing/2014/main" id="{14F02541-D176-4D5B-AAA5-F7F2D22BC1B8}"/>
               </a:ext>
             </a:extLst>
           </p:cNvPr>
@@ -2717,7 +2717,7 @@
                 <a:ea typeface="Arial"/>
                 <a:cs typeface="Arial"/>
               </a:rPr>
-              <a:t>Сравнение BS-кандидатов</a:t>
+              <a:t>Итоговая поставка</a:t>
             </a:r>
           </a:p>
           <a:p xmlns:a="http://schemas.openxmlformats.org/drawingml/2006/main">
@@ -2740,7 +2740,7 @@
                 <a:ea typeface="Arial"/>
                 <a:cs typeface="Arial"/>
               </a:rPr>
-              <a:t>Итоговая поставка</a:t>
+              <a:t>и GitVerse</a:t>
             </a:r>
           </a:p>
         </p:txBody>
@@ -2750,7 +2750,7 @@
           <p:cNvPr id="10" name="">
             <a:extLst xmlns:a="http://schemas.openxmlformats.org/drawingml/2006/main">
               <a:ext uri="{FF2B5EF4-FFF2-40B4-BE49-F238E27FC236}">
-                <a16:creationId xmlns:a16="http://schemas.microsoft.com/office/drawing/2014/main" id="{44B22ABA-CBB9-42D5-B6F1-1FE93BA341D4}"/>
+                <a16:creationId xmlns:a16="http://schemas.microsoft.com/office/drawing/2014/main" id="{BE2B4003-51B9-4571-A4C3-7FC1AD252F62}"/>
               </a:ext>
             </a:extLst>
           </p:cNvPr>
@@ -2797,7 +2797,7 @@
                 <a:ea typeface="Arial"/>
                 <a:cs typeface="Arial"/>
               </a:rPr>
-              <a:t>Публичный E2E, rollback и parity CPU Windows/Linux на 4 сценах: PASS.</a:t>
+              <a:t>V3 service: E2E 91 HTTP / 6 jobs; rollback и parity raw mask Windows/Linux: PASS.</a:t>
             </a:r>
           </a:p>
         </p:txBody>
@@ -2807,7 +2807,7 @@
           <p:cNvPr id="11" name="">
             <a:extLst xmlns:a="http://schemas.openxmlformats.org/drawingml/2006/main">
               <a:ext uri="{FF2B5EF4-FFF2-40B4-BE49-F238E27FC236}">
-                <a16:creationId xmlns:a16="http://schemas.microsoft.com/office/drawing/2014/main" id="{B7FD3F82-F8E5-48A5-82C0-642B39284BD8}"/>
+                <a16:creationId xmlns:a16="http://schemas.microsoft.com/office/drawing/2014/main" id="{63E79747-C7B7-4097-816F-A1AA57FA8813}"/>
               </a:ext>
             </a:extLst>
           </p:cNvPr>
@@ -2864,7 +2864,7 @@
           <p:cNvPr id="12" name="">
             <a:extLst xmlns:a="http://schemas.openxmlformats.org/drawingml/2006/main">
               <a:ext uri="{FF2B5EF4-FFF2-40B4-BE49-F238E27FC236}">
-                <a16:creationId xmlns:a16="http://schemas.microsoft.com/office/drawing/2014/main" id="{1282AF94-2CB6-4B8F-8199-13CF2280AF9D}"/>
+                <a16:creationId xmlns:a16="http://schemas.microsoft.com/office/drawing/2014/main" id="{412A4314-3BB3-4D75-B9B5-88BD0A8E56DB}"/>
               </a:ext>
             </a:extLst>
           </p:cNvPr>
@@ -2921,7 +2921,7 @@
           <p:cNvPr id="13" name="">
             <a:extLst xmlns:a="http://schemas.openxmlformats.org/drawingml/2006/main">
               <a:ext uri="{FF2B5EF4-FFF2-40B4-BE49-F238E27FC236}">
-                <a16:creationId xmlns:a16="http://schemas.microsoft.com/office/drawing/2014/main" id="{BAFF1C16-FD91-4367-BE74-9C1DF0670506}"/>
+                <a16:creationId xmlns:a16="http://schemas.microsoft.com/office/drawing/2014/main" id="{55BB7F30-4B0B-4E96-A43E-B9008693A52A}"/>
               </a:ext>
             </a:extLst>
           </p:cNvPr>
@@ -2978,7 +2978,7 @@
           <p:cNvPr id="14" name="">
             <a:extLst xmlns:a="http://schemas.openxmlformats.org/drawingml/2006/main">
               <a:ext uri="{FF2B5EF4-FFF2-40B4-BE49-F238E27FC236}">
-                <a16:creationId xmlns:a16="http://schemas.microsoft.com/office/drawing/2014/main" id="{E4B2F098-8A21-4EDC-9109-A03E6E5D7D25}"/>
+                <a16:creationId xmlns:a16="http://schemas.microsoft.com/office/drawing/2014/main" id="{DC1BA7EC-BC41-4B81-AA13-3A5ECC1CE987}"/>
               </a:ext>
             </a:extLst>
           </p:cNvPr>
@@ -3033,7 +3033,7 @@
     </p:spTree>
     <p:extLst>
       <p:ext uri="{BB962C8B-B14F-4D97-AF65-F5344CB8AC3E}">
-        <p14:creationId xmlns:p14="http://schemas.microsoft.com/office/powerpoint/2010/main" val="1374137987"/>
+        <p14:creationId xmlns:p14="http://schemas.microsoft.com/office/powerpoint/2010/main" val="47005488"/>
       </p:ext>
     </p:extLst>
   </p:cSld>
@@ -3064,7 +3064,7 @@
           <p:cNvPr id="13" name="">
             <a:extLst xmlns:a="http://schemas.openxmlformats.org/drawingml/2006/main">
               <a:ext uri="{FF2B5EF4-FFF2-40B4-BE49-F238E27FC236}">
-                <a16:creationId xmlns:a16="http://schemas.microsoft.com/office/drawing/2014/main" id="{BF1FC977-52BE-44DF-8F21-D5E4FF7E7EB4}"/>
+                <a16:creationId xmlns:a16="http://schemas.microsoft.com/office/drawing/2014/main" id="{C1E7BD75-87D1-40E1-9759-4E2597B70703}"/>
               </a:ext>
             </a:extLst>
           </p:cNvPr>
@@ -3096,7 +3096,7 @@
           <p:cNvPr id="2" name="">
             <a:extLst xmlns:a="http://schemas.openxmlformats.org/drawingml/2006/main">
               <a:ext uri="{FF2B5EF4-FFF2-40B4-BE49-F238E27FC236}">
-                <a16:creationId xmlns:a16="http://schemas.microsoft.com/office/drawing/2014/main" id="{0FE1EC79-6703-4A0E-817F-3BA5C2B40659}"/>
+                <a16:creationId xmlns:a16="http://schemas.microsoft.com/office/drawing/2014/main" id="{D5C590BC-768D-4B95-A9E2-9F7DD8FB73E0}"/>
               </a:ext>
             </a:extLst>
           </p:cNvPr>
@@ -3153,7 +3153,7 @@
           <p:cNvPr id="3" name="">
             <a:extLst xmlns:a="http://schemas.openxmlformats.org/drawingml/2006/main">
               <a:ext uri="{FF2B5EF4-FFF2-40B4-BE49-F238E27FC236}">
-                <a16:creationId xmlns:a16="http://schemas.microsoft.com/office/drawing/2014/main" id="{4F06215E-E612-4B07-9940-F3A820AEB26B}"/>
+                <a16:creationId xmlns:a16="http://schemas.microsoft.com/office/drawing/2014/main" id="{9B91BBC1-5A37-477B-AA3F-56B3CAC28F1B}"/>
               </a:ext>
             </a:extLst>
           </p:cNvPr>
@@ -3210,7 +3210,7 @@
           <p:cNvPr id="4" name="">
             <a:extLst xmlns:a="http://schemas.openxmlformats.org/drawingml/2006/main">
               <a:ext uri="{FF2B5EF4-FFF2-40B4-BE49-F238E27FC236}">
-                <a16:creationId xmlns:a16="http://schemas.microsoft.com/office/drawing/2014/main" id="{3E82D213-8635-449C-B405-1DC51B46BAFA}"/>
+                <a16:creationId xmlns:a16="http://schemas.microsoft.com/office/drawing/2014/main" id="{9C26EDBB-538A-4F10-861B-E28D9FABEC26}"/>
               </a:ext>
             </a:extLst>
           </p:cNvPr>
@@ -3267,7 +3267,7 @@
           <p:cNvPr id="5" name="">
             <a:extLst xmlns:a="http://schemas.openxmlformats.org/drawingml/2006/main">
               <a:ext uri="{FF2B5EF4-FFF2-40B4-BE49-F238E27FC236}">
-                <a16:creationId xmlns:a16="http://schemas.microsoft.com/office/drawing/2014/main" id="{A8C56156-0946-4436-ABA6-4FF5D148BDA9}"/>
+                <a16:creationId xmlns:a16="http://schemas.microsoft.com/office/drawing/2014/main" id="{1251AFE0-8C4D-49C5-A101-7D5BE43EBDE7}"/>
               </a:ext>
             </a:extLst>
           </p:cNvPr>
@@ -3299,7 +3299,7 @@
           <p:cNvPr id="6" name="">
             <a:extLst xmlns:a="http://schemas.openxmlformats.org/drawingml/2006/main">
               <a:ext uri="{FF2B5EF4-FFF2-40B4-BE49-F238E27FC236}">
-                <a16:creationId xmlns:a16="http://schemas.microsoft.com/office/drawing/2014/main" id="{315D6580-B9A1-4453-96D5-8C385EC85CF9}"/>
+                <a16:creationId xmlns:a16="http://schemas.microsoft.com/office/drawing/2014/main" id="{5F8C337C-7841-40AD-BFDA-AB1686B5FB15}"/>
               </a:ext>
             </a:extLst>
           </p:cNvPr>
@@ -3331,7 +3331,7 @@
           <p:cNvPr id="7" name="">
             <a:extLst xmlns:a="http://schemas.openxmlformats.org/drawingml/2006/main">
               <a:ext uri="{FF2B5EF4-FFF2-40B4-BE49-F238E27FC236}">
-                <a16:creationId xmlns:a16="http://schemas.microsoft.com/office/drawing/2014/main" id="{7D74CEBC-9720-4AFD-BE43-0475E1D8C31F}"/>
+                <a16:creationId xmlns:a16="http://schemas.microsoft.com/office/drawing/2014/main" id="{C4414F20-025D-4CB3-A2D2-B2593697E4AD}"/>
               </a:ext>
             </a:extLst>
           </p:cNvPr>
@@ -3388,7 +3388,7 @@
           <p:cNvPr id="8" name="">
             <a:extLst xmlns:a="http://schemas.openxmlformats.org/drawingml/2006/main">
               <a:ext uri="{FF2B5EF4-FFF2-40B4-BE49-F238E27FC236}">
-                <a16:creationId xmlns:a16="http://schemas.microsoft.com/office/drawing/2014/main" id="{88B85C5F-3C63-4357-951A-8EBC3C058DC2}"/>
+                <a16:creationId xmlns:a16="http://schemas.microsoft.com/office/drawing/2014/main" id="{85E1807B-1A66-4664-955B-959B6B5680E4}"/>
               </a:ext>
             </a:extLst>
           </p:cNvPr>
@@ -3445,7 +3445,7 @@
           <p:cNvPr id="9" name="">
             <a:extLst xmlns:a="http://schemas.openxmlformats.org/drawingml/2006/main">
               <a:ext uri="{FF2B5EF4-FFF2-40B4-BE49-F238E27FC236}">
-                <a16:creationId xmlns:a16="http://schemas.microsoft.com/office/drawing/2014/main" id="{11B860E9-9CDE-4759-B012-1A9068BD6CB6}"/>
+                <a16:creationId xmlns:a16="http://schemas.microsoft.com/office/drawing/2014/main" id="{49FA73DF-2474-47B1-B600-DEB3A7C6F92F}"/>
               </a:ext>
             </a:extLst>
           </p:cNvPr>
@@ -3502,7 +3502,7 @@
           <p:cNvPr id="10" name="">
             <a:extLst xmlns:a="http://schemas.openxmlformats.org/drawingml/2006/main">
               <a:ext uri="{FF2B5EF4-FFF2-40B4-BE49-F238E27FC236}">
-                <a16:creationId xmlns:a16="http://schemas.microsoft.com/office/drawing/2014/main" id="{6C2B3DF8-3479-4A98-AB77-3F8013850791}"/>
+                <a16:creationId xmlns:a16="http://schemas.microsoft.com/office/drawing/2014/main" id="{79AF6154-6F24-48EA-B247-AA8AAFD28153}"/>
               </a:ext>
             </a:extLst>
           </p:cNvPr>
@@ -3559,7 +3559,7 @@
           <p:cNvPr id="11" name="">
             <a:extLst xmlns:a="http://schemas.openxmlformats.org/drawingml/2006/main">
               <a:ext uri="{FF2B5EF4-FFF2-40B4-BE49-F238E27FC236}">
-                <a16:creationId xmlns:a16="http://schemas.microsoft.com/office/drawing/2014/main" id="{FDDC623F-9E6A-479F-B9B7-7AE09C69646B}"/>
+                <a16:creationId xmlns:a16="http://schemas.microsoft.com/office/drawing/2014/main" id="{FDAF81C6-CDF6-4022-8209-21715A93AE04}"/>
               </a:ext>
             </a:extLst>
           </p:cNvPr>
@@ -3616,7 +3616,7 @@
           <p:cNvPr id="12" name="">
             <a:extLst xmlns:a="http://schemas.openxmlformats.org/drawingml/2006/main">
               <a:ext uri="{FF2B5EF4-FFF2-40B4-BE49-F238E27FC236}">
-                <a16:creationId xmlns:a16="http://schemas.microsoft.com/office/drawing/2014/main" id="{5BD2C2C2-43F5-4C10-AFFD-F3EAF9300ACB}"/>
+                <a16:creationId xmlns:a16="http://schemas.microsoft.com/office/drawing/2014/main" id="{C4BDB483-2119-4F0C-BCCD-1E3D658C4070}"/>
               </a:ext>
             </a:extLst>
           </p:cNvPr>
@@ -3671,7 +3671,7 @@
     </p:spTree>
     <p:extLst>
       <p:ext uri="{BB962C8B-B14F-4D97-AF65-F5344CB8AC3E}">
-        <p14:creationId xmlns:p14="http://schemas.microsoft.com/office/powerpoint/2010/main" val="1293564760"/>
+        <p14:creationId xmlns:p14="http://schemas.microsoft.com/office/powerpoint/2010/main" val="796522973"/>
       </p:ext>
     </p:extLst>
   </p:cSld>
@@ -3702,7 +3702,7 @@
           <p:cNvPr id="12" name="">
             <a:extLst xmlns:a="http://schemas.openxmlformats.org/drawingml/2006/main">
               <a:ext uri="{FF2B5EF4-FFF2-40B4-BE49-F238E27FC236}">
-                <a16:creationId xmlns:a16="http://schemas.microsoft.com/office/drawing/2014/main" id="{58C6FC54-3B9D-46D4-841B-2808A1264715}"/>
+                <a16:creationId xmlns:a16="http://schemas.microsoft.com/office/drawing/2014/main" id="{921077D6-945F-4FD8-8851-3CB527A1C83E}"/>
               </a:ext>
             </a:extLst>
           </p:cNvPr>
@@ -3734,7 +3734,7 @@
           <p:cNvPr id="2" name="">
             <a:extLst xmlns:a="http://schemas.openxmlformats.org/drawingml/2006/main">
               <a:ext uri="{FF2B5EF4-FFF2-40B4-BE49-F238E27FC236}">
-                <a16:creationId xmlns:a16="http://schemas.microsoft.com/office/drawing/2014/main" id="{F6223B33-FE03-4B88-B7FE-FCBD282B106A}"/>
+                <a16:creationId xmlns:a16="http://schemas.microsoft.com/office/drawing/2014/main" id="{4372685A-F6D4-430A-9507-F322B0BC6170}"/>
               </a:ext>
             </a:extLst>
           </p:cNvPr>
@@ -3791,7 +3791,7 @@
           <p:cNvPr id="3" name="">
             <a:extLst xmlns:a="http://schemas.openxmlformats.org/drawingml/2006/main">
               <a:ext uri="{FF2B5EF4-FFF2-40B4-BE49-F238E27FC236}">
-                <a16:creationId xmlns:a16="http://schemas.microsoft.com/office/drawing/2014/main" id="{DD522787-F2F0-46DE-9D5B-966734A68ADF}"/>
+                <a16:creationId xmlns:a16="http://schemas.microsoft.com/office/drawing/2014/main" id="{5EB5AD37-A5B8-4762-8BFF-C3571CC41608}"/>
               </a:ext>
             </a:extLst>
           </p:cNvPr>
@@ -3848,7 +3848,7 @@
           <p:cNvPr id="4" name="">
             <a:extLst xmlns:a="http://schemas.openxmlformats.org/drawingml/2006/main">
               <a:ext uri="{FF2B5EF4-FFF2-40B4-BE49-F238E27FC236}">
-                <a16:creationId xmlns:a16="http://schemas.microsoft.com/office/drawing/2014/main" id="{44C9AA3E-873C-456F-84A5-171744BA018C}"/>
+                <a16:creationId xmlns:a16="http://schemas.microsoft.com/office/drawing/2014/main" id="{5EDD540A-8C36-448D-B47C-38A36715ADD6}"/>
               </a:ext>
             </a:extLst>
           </p:cNvPr>
@@ -3905,7 +3905,7 @@
           <p:cNvPr id="5" name="">
             <a:extLst xmlns:a="http://schemas.openxmlformats.org/drawingml/2006/main">
               <a:ext uri="{FF2B5EF4-FFF2-40B4-BE49-F238E27FC236}">
-                <a16:creationId xmlns:a16="http://schemas.microsoft.com/office/drawing/2014/main" id="{9300546C-F466-4DB6-A236-D377C0EFD293}"/>
+                <a16:creationId xmlns:a16="http://schemas.microsoft.com/office/drawing/2014/main" id="{A6D5D317-51C8-4139-838B-95B462AD8E37}"/>
               </a:ext>
             </a:extLst>
           </p:cNvPr>
@@ -4008,7 +4008,7 @@
           <p:cNvPr id="6" name="">
             <a:extLst xmlns:a="http://schemas.openxmlformats.org/drawingml/2006/main">
               <a:ext uri="{FF2B5EF4-FFF2-40B4-BE49-F238E27FC236}">
-                <a16:creationId xmlns:a16="http://schemas.microsoft.com/office/drawing/2014/main" id="{34861D78-4F7E-4940-BE9F-543B0FC976CE}"/>
+                <a16:creationId xmlns:a16="http://schemas.microsoft.com/office/drawing/2014/main" id="{4C6D04FC-0F12-4539-BE92-967C858200AA}"/>
               </a:ext>
             </a:extLst>
           </p:cNvPr>
@@ -4088,7 +4088,7 @@
           <p:cNvPr id="7" name="">
             <a:extLst xmlns:a="http://schemas.openxmlformats.org/drawingml/2006/main">
               <a:ext uri="{FF2B5EF4-FFF2-40B4-BE49-F238E27FC236}">
-                <a16:creationId xmlns:a16="http://schemas.microsoft.com/office/drawing/2014/main" id="{AEE2AFA1-1FE9-4EB7-861F-F52879D59231}"/>
+                <a16:creationId xmlns:a16="http://schemas.microsoft.com/office/drawing/2014/main" id="{45657021-D8F2-46E3-9049-5C2D175989AA}"/>
               </a:ext>
             </a:extLst>
           </p:cNvPr>
@@ -4118,7 +4118,7 @@
           <p:cNvPr id="8" name="">
             <a:extLst xmlns:a="http://schemas.openxmlformats.org/drawingml/2006/main">
               <a:ext uri="{FF2B5EF4-FFF2-40B4-BE49-F238E27FC236}">
-                <a16:creationId xmlns:a16="http://schemas.microsoft.com/office/drawing/2014/main" id="{6EB80F8E-A8EE-4C37-8651-6F6E0A0E17E8}"/>
+                <a16:creationId xmlns:a16="http://schemas.microsoft.com/office/drawing/2014/main" id="{1F78479F-B45F-42D5-813C-3C26DD2C9AA6}"/>
               </a:ext>
             </a:extLst>
           </p:cNvPr>
@@ -4175,7 +4175,7 @@
           <p:cNvPr id="9" name="">
             <a:extLst xmlns:a="http://schemas.openxmlformats.org/drawingml/2006/main">
               <a:ext uri="{FF2B5EF4-FFF2-40B4-BE49-F238E27FC236}">
-                <a16:creationId xmlns:a16="http://schemas.microsoft.com/office/drawing/2014/main" id="{2DF910DD-A787-41D8-929C-CCA6F17A298C}"/>
+                <a16:creationId xmlns:a16="http://schemas.microsoft.com/office/drawing/2014/main" id="{0C5C95E7-320A-46EB-8448-78136AA51035}"/>
               </a:ext>
             </a:extLst>
           </p:cNvPr>
@@ -4301,7 +4301,7 @@
           <p:cNvPr id="10" name="">
             <a:extLst xmlns:a="http://schemas.openxmlformats.org/drawingml/2006/main">
               <a:ext uri="{FF2B5EF4-FFF2-40B4-BE49-F238E27FC236}">
-                <a16:creationId xmlns:a16="http://schemas.microsoft.com/office/drawing/2014/main" id="{D1DE8EF8-3037-4D57-90BD-380EB22B0AB1}"/>
+                <a16:creationId xmlns:a16="http://schemas.microsoft.com/office/drawing/2014/main" id="{8C56C767-7BED-4339-AAE2-F1FB3B618321}"/>
               </a:ext>
             </a:extLst>
           </p:cNvPr>
@@ -4381,7 +4381,7 @@
           <p:cNvPr id="11" name="">
             <a:extLst xmlns:a="http://schemas.openxmlformats.org/drawingml/2006/main">
               <a:ext uri="{FF2B5EF4-FFF2-40B4-BE49-F238E27FC236}">
-                <a16:creationId xmlns:a16="http://schemas.microsoft.com/office/drawing/2014/main" id="{5FA5110E-EEFD-40BD-BEDA-28533AEC47CE}"/>
+                <a16:creationId xmlns:a16="http://schemas.microsoft.com/office/drawing/2014/main" id="{40BE6AFC-1EA8-441F-AB54-53CB23C82747}"/>
               </a:ext>
             </a:extLst>
           </p:cNvPr>
@@ -4436,7 +4436,7 @@
     </p:spTree>
     <p:extLst>
       <p:ext uri="{BB962C8B-B14F-4D97-AF65-F5344CB8AC3E}">
-        <p14:creationId xmlns:p14="http://schemas.microsoft.com/office/powerpoint/2010/main" val="961893848"/>
+        <p14:creationId xmlns:p14="http://schemas.microsoft.com/office/powerpoint/2010/main" val="1814061630"/>
       </p:ext>
     </p:extLst>
   </p:cSld>
@@ -4467,7 +4467,7 @@
           <p:cNvPr id="29" name="">
             <a:extLst xmlns:a="http://schemas.openxmlformats.org/drawingml/2006/main">
               <a:ext uri="{FF2B5EF4-FFF2-40B4-BE49-F238E27FC236}">
-                <a16:creationId xmlns:a16="http://schemas.microsoft.com/office/drawing/2014/main" id="{9C669736-D692-4F1A-88FB-18C5CC33E388}"/>
+                <a16:creationId xmlns:a16="http://schemas.microsoft.com/office/drawing/2014/main" id="{4BDC852E-6CA1-4027-886F-FBF8208C8AB6}"/>
               </a:ext>
             </a:extLst>
           </p:cNvPr>
@@ -4499,7 +4499,7 @@
           <p:cNvPr id="2" name="">
             <a:extLst xmlns:a="http://schemas.openxmlformats.org/drawingml/2006/main">
               <a:ext uri="{FF2B5EF4-FFF2-40B4-BE49-F238E27FC236}">
-                <a16:creationId xmlns:a16="http://schemas.microsoft.com/office/drawing/2014/main" id="{FB4CF1A2-75BB-498A-B09F-158C810BFC77}"/>
+                <a16:creationId xmlns:a16="http://schemas.microsoft.com/office/drawing/2014/main" id="{D0D398C8-FEEE-45A0-8219-94F666EC9595}"/>
               </a:ext>
             </a:extLst>
           </p:cNvPr>
@@ -4556,7 +4556,7 @@
           <p:cNvPr id="3" name="">
             <a:extLst xmlns:a="http://schemas.openxmlformats.org/drawingml/2006/main">
               <a:ext uri="{FF2B5EF4-FFF2-40B4-BE49-F238E27FC236}">
-                <a16:creationId xmlns:a16="http://schemas.microsoft.com/office/drawing/2014/main" id="{13AD0C96-2E27-4E58-A3B7-1EBC3B55417A}"/>
+                <a16:creationId xmlns:a16="http://schemas.microsoft.com/office/drawing/2014/main" id="{D084B686-A504-438D-88A6-D5891DA698AE}"/>
               </a:ext>
             </a:extLst>
           </p:cNvPr>
@@ -4613,7 +4613,7 @@
           <p:cNvPr id="4" name="">
             <a:extLst xmlns:a="http://schemas.openxmlformats.org/drawingml/2006/main">
               <a:ext uri="{FF2B5EF4-FFF2-40B4-BE49-F238E27FC236}">
-                <a16:creationId xmlns:a16="http://schemas.microsoft.com/office/drawing/2014/main" id="{5B90CABF-ACC0-47F4-B8BF-E92BC5147114}"/>
+                <a16:creationId xmlns:a16="http://schemas.microsoft.com/office/drawing/2014/main" id="{24DF52B4-92E3-44B7-876B-C9A2B9B46D41}"/>
               </a:ext>
             </a:extLst>
           </p:cNvPr>
@@ -4645,7 +4645,7 @@
           <p:cNvPr id="5" name="">
             <a:extLst xmlns:a="http://schemas.openxmlformats.org/drawingml/2006/main">
               <a:ext uri="{FF2B5EF4-FFF2-40B4-BE49-F238E27FC236}">
-                <a16:creationId xmlns:a16="http://schemas.microsoft.com/office/drawing/2014/main" id="{39280099-B1EB-436B-BECD-293E47DE7388}"/>
+                <a16:creationId xmlns:a16="http://schemas.microsoft.com/office/drawing/2014/main" id="{C3183208-6423-4270-8FB9-A722C7DA5E9A}"/>
               </a:ext>
             </a:extLst>
           </p:cNvPr>
@@ -4702,7 +4702,7 @@
           <p:cNvPr id="6" name="">
             <a:extLst xmlns:a="http://schemas.openxmlformats.org/drawingml/2006/main">
               <a:ext uri="{FF2B5EF4-FFF2-40B4-BE49-F238E27FC236}">
-                <a16:creationId xmlns:a16="http://schemas.microsoft.com/office/drawing/2014/main" id="{1426B153-486E-4EAC-A6DC-07B76114DE3B}"/>
+                <a16:creationId xmlns:a16="http://schemas.microsoft.com/office/drawing/2014/main" id="{FFC1E37D-EAE5-4470-A515-8ECF7FA0F780}"/>
               </a:ext>
             </a:extLst>
           </p:cNvPr>
@@ -4759,7 +4759,7 @@
           <p:cNvPr id="7" name="">
             <a:extLst xmlns:a="http://schemas.openxmlformats.org/drawingml/2006/main">
               <a:ext uri="{FF2B5EF4-FFF2-40B4-BE49-F238E27FC236}">
-                <a16:creationId xmlns:a16="http://schemas.microsoft.com/office/drawing/2014/main" id="{C0670E29-B585-4911-AC05-2E561EB3320A}"/>
+                <a16:creationId xmlns:a16="http://schemas.microsoft.com/office/drawing/2014/main" id="{8605C32B-A58C-49A1-866F-35BEF52C407A}"/>
               </a:ext>
             </a:extLst>
           </p:cNvPr>
@@ -4839,7 +4839,7 @@
           <p:cNvPr id="8" name="">
             <a:extLst xmlns:a="http://schemas.openxmlformats.org/drawingml/2006/main">
               <a:ext uri="{FF2B5EF4-FFF2-40B4-BE49-F238E27FC236}">
-                <a16:creationId xmlns:a16="http://schemas.microsoft.com/office/drawing/2014/main" id="{02A10F8E-055F-4F5B-B4DD-0D30B96B15F7}"/>
+                <a16:creationId xmlns:a16="http://schemas.microsoft.com/office/drawing/2014/main" id="{F6992ACD-5612-4EAD-BC12-F83C8443942D}"/>
               </a:ext>
             </a:extLst>
           </p:cNvPr>
@@ -4896,7 +4896,7 @@
           <p:cNvPr id="9" name="">
             <a:extLst xmlns:a="http://schemas.openxmlformats.org/drawingml/2006/main">
               <a:ext uri="{FF2B5EF4-FFF2-40B4-BE49-F238E27FC236}">
-                <a16:creationId xmlns:a16="http://schemas.microsoft.com/office/drawing/2014/main" id="{7FBD984C-84C2-47EE-8B7C-CBEE141EC394}"/>
+                <a16:creationId xmlns:a16="http://schemas.microsoft.com/office/drawing/2014/main" id="{565D7D8E-8484-405D-9AC4-9991173CBC16}"/>
               </a:ext>
             </a:extLst>
           </p:cNvPr>
@@ -4928,7 +4928,7 @@
           <p:cNvPr id="10" name="">
             <a:extLst xmlns:a="http://schemas.openxmlformats.org/drawingml/2006/main">
               <a:ext uri="{FF2B5EF4-FFF2-40B4-BE49-F238E27FC236}">
-                <a16:creationId xmlns:a16="http://schemas.microsoft.com/office/drawing/2014/main" id="{150A138E-9B4E-40CE-942B-ECB9373ABDE2}"/>
+                <a16:creationId xmlns:a16="http://schemas.microsoft.com/office/drawing/2014/main" id="{29D72AD8-BEF6-4BCD-994F-2A6046F07981}"/>
               </a:ext>
             </a:extLst>
           </p:cNvPr>
@@ -4985,7 +4985,7 @@
           <p:cNvPr id="11" name="">
             <a:extLst xmlns:a="http://schemas.openxmlformats.org/drawingml/2006/main">
               <a:ext uri="{FF2B5EF4-FFF2-40B4-BE49-F238E27FC236}">
-                <a16:creationId xmlns:a16="http://schemas.microsoft.com/office/drawing/2014/main" id="{4CF00881-A408-42B9-8B09-FA9970E5C6D6}"/>
+                <a16:creationId xmlns:a16="http://schemas.microsoft.com/office/drawing/2014/main" id="{61BD3A55-B971-495A-93D4-C5C03C365C0D}"/>
               </a:ext>
             </a:extLst>
           </p:cNvPr>
@@ -5042,7 +5042,7 @@
           <p:cNvPr id="12" name="">
             <a:extLst xmlns:a="http://schemas.openxmlformats.org/drawingml/2006/main">
               <a:ext uri="{FF2B5EF4-FFF2-40B4-BE49-F238E27FC236}">
-                <a16:creationId xmlns:a16="http://schemas.microsoft.com/office/drawing/2014/main" id="{A923112A-7A96-43CF-80E1-2395E17C76CA}"/>
+                <a16:creationId xmlns:a16="http://schemas.microsoft.com/office/drawing/2014/main" id="{B92553F0-687E-4A45-AC68-9BC000DA440A}"/>
               </a:ext>
             </a:extLst>
           </p:cNvPr>
@@ -5122,7 +5122,7 @@
           <p:cNvPr id="13" name="">
             <a:extLst xmlns:a="http://schemas.openxmlformats.org/drawingml/2006/main">
               <a:ext uri="{FF2B5EF4-FFF2-40B4-BE49-F238E27FC236}">
-                <a16:creationId xmlns:a16="http://schemas.microsoft.com/office/drawing/2014/main" id="{2E2B46EB-5CA4-4424-BDA6-C21B5558B7EB}"/>
+                <a16:creationId xmlns:a16="http://schemas.microsoft.com/office/drawing/2014/main" id="{CB8B4A2F-2C18-4841-A624-67EF864839A1}"/>
               </a:ext>
             </a:extLst>
           </p:cNvPr>
@@ -5179,7 +5179,7 @@
           <p:cNvPr id="14" name="">
             <a:extLst xmlns:a="http://schemas.openxmlformats.org/drawingml/2006/main">
               <a:ext uri="{FF2B5EF4-FFF2-40B4-BE49-F238E27FC236}">
-                <a16:creationId xmlns:a16="http://schemas.microsoft.com/office/drawing/2014/main" id="{B11F7200-E1BF-4958-8665-794CBB95A3F6}"/>
+                <a16:creationId xmlns:a16="http://schemas.microsoft.com/office/drawing/2014/main" id="{BA4B2C5D-B7D5-4726-88D9-F444E00914A9}"/>
               </a:ext>
             </a:extLst>
           </p:cNvPr>
@@ -5211,7 +5211,7 @@
           <p:cNvPr id="15" name="">
             <a:extLst xmlns:a="http://schemas.openxmlformats.org/drawingml/2006/main">
               <a:ext uri="{FF2B5EF4-FFF2-40B4-BE49-F238E27FC236}">
-                <a16:creationId xmlns:a16="http://schemas.microsoft.com/office/drawing/2014/main" id="{019E6169-EEA8-49DE-83B1-D35558BCFE6E}"/>
+                <a16:creationId xmlns:a16="http://schemas.microsoft.com/office/drawing/2014/main" id="{E199CCB2-A9FB-4746-A75F-05E96870204A}"/>
               </a:ext>
             </a:extLst>
           </p:cNvPr>
@@ -5268,7 +5268,7 @@
           <p:cNvPr id="16" name="">
             <a:extLst xmlns:a="http://schemas.openxmlformats.org/drawingml/2006/main">
               <a:ext uri="{FF2B5EF4-FFF2-40B4-BE49-F238E27FC236}">
-                <a16:creationId xmlns:a16="http://schemas.microsoft.com/office/drawing/2014/main" id="{3CB63FCA-0F34-4135-8D73-2C9B7CB3EFE6}"/>
+                <a16:creationId xmlns:a16="http://schemas.microsoft.com/office/drawing/2014/main" id="{43B27B08-61BB-47F7-BE5B-DE0394B258A1}"/>
               </a:ext>
             </a:extLst>
           </p:cNvPr>
@@ -5325,7 +5325,7 @@
           <p:cNvPr id="17" name="">
             <a:extLst xmlns:a="http://schemas.openxmlformats.org/drawingml/2006/main">
               <a:ext uri="{FF2B5EF4-FFF2-40B4-BE49-F238E27FC236}">
-                <a16:creationId xmlns:a16="http://schemas.microsoft.com/office/drawing/2014/main" id="{34C0E5BD-42F4-4A17-9D27-5E223B5E1007}"/>
+                <a16:creationId xmlns:a16="http://schemas.microsoft.com/office/drawing/2014/main" id="{A476811B-71B7-4206-ACCB-797A9D995CEC}"/>
               </a:ext>
             </a:extLst>
           </p:cNvPr>
@@ -5405,7 +5405,7 @@
           <p:cNvPr id="18" name="">
             <a:extLst xmlns:a="http://schemas.openxmlformats.org/drawingml/2006/main">
               <a:ext uri="{FF2B5EF4-FFF2-40B4-BE49-F238E27FC236}">
-                <a16:creationId xmlns:a16="http://schemas.microsoft.com/office/drawing/2014/main" id="{833E2814-805A-4E19-B0C2-247506A27A61}"/>
+                <a16:creationId xmlns:a16="http://schemas.microsoft.com/office/drawing/2014/main" id="{ECA0D1D0-B3BA-4AB8-A489-8BF1016B7B03}"/>
               </a:ext>
             </a:extLst>
           </p:cNvPr>
@@ -5462,7 +5462,7 @@
           <p:cNvPr id="19" name="">
             <a:extLst xmlns:a="http://schemas.openxmlformats.org/drawingml/2006/main">
               <a:ext uri="{FF2B5EF4-FFF2-40B4-BE49-F238E27FC236}">
-                <a16:creationId xmlns:a16="http://schemas.microsoft.com/office/drawing/2014/main" id="{CE84E036-23F7-4BDD-BD6C-B810312AD2F5}"/>
+                <a16:creationId xmlns:a16="http://schemas.microsoft.com/office/drawing/2014/main" id="{BB54BD22-7E0B-46B6-A007-8A7202DC01A3}"/>
               </a:ext>
             </a:extLst>
           </p:cNvPr>
@@ -5494,7 +5494,7 @@
           <p:cNvPr id="20" name="">
             <a:extLst xmlns:a="http://schemas.openxmlformats.org/drawingml/2006/main">
               <a:ext uri="{FF2B5EF4-FFF2-40B4-BE49-F238E27FC236}">
-                <a16:creationId xmlns:a16="http://schemas.microsoft.com/office/drawing/2014/main" id="{4769C0E2-5C9C-4477-A040-E6B495930A71}"/>
+                <a16:creationId xmlns:a16="http://schemas.microsoft.com/office/drawing/2014/main" id="{B1401266-39A6-4C1E-AC58-4DBA97914F3C}"/>
               </a:ext>
             </a:extLst>
           </p:cNvPr>
@@ -5551,7 +5551,7 @@
           <p:cNvPr id="21" name="">
             <a:extLst xmlns:a="http://schemas.openxmlformats.org/drawingml/2006/main">
               <a:ext uri="{FF2B5EF4-FFF2-40B4-BE49-F238E27FC236}">
-                <a16:creationId xmlns:a16="http://schemas.microsoft.com/office/drawing/2014/main" id="{B776E52C-F242-4389-86E1-F4B7A80CF0F9}"/>
+                <a16:creationId xmlns:a16="http://schemas.microsoft.com/office/drawing/2014/main" id="{AADB89C3-9F45-4BB3-91A9-C3D937D48509}"/>
               </a:ext>
             </a:extLst>
           </p:cNvPr>
@@ -5608,7 +5608,7 @@
           <p:cNvPr id="22" name="">
             <a:extLst xmlns:a="http://schemas.openxmlformats.org/drawingml/2006/main">
               <a:ext uri="{FF2B5EF4-FFF2-40B4-BE49-F238E27FC236}">
-                <a16:creationId xmlns:a16="http://schemas.microsoft.com/office/drawing/2014/main" id="{FBCC8688-7921-4089-B1BB-F8A979B63F65}"/>
+                <a16:creationId xmlns:a16="http://schemas.microsoft.com/office/drawing/2014/main" id="{E01DF4FC-B3E9-4C2E-879C-4ED1F9C3EA27}"/>
               </a:ext>
             </a:extLst>
           </p:cNvPr>
@@ -5688,7 +5688,7 @@
           <p:cNvPr id="23" name="">
             <a:extLst xmlns:a="http://schemas.openxmlformats.org/drawingml/2006/main">
               <a:ext uri="{FF2B5EF4-FFF2-40B4-BE49-F238E27FC236}">
-                <a16:creationId xmlns:a16="http://schemas.microsoft.com/office/drawing/2014/main" id="{CD8F9211-D1EB-4ACA-AE50-4380AF980A43}"/>
+                <a16:creationId xmlns:a16="http://schemas.microsoft.com/office/drawing/2014/main" id="{B17F3118-98C9-4E92-8BB9-FFB426B64467}"/>
               </a:ext>
             </a:extLst>
           </p:cNvPr>
@@ -5745,7 +5745,7 @@
           <p:cNvPr id="24" name="">
             <a:extLst xmlns:a="http://schemas.openxmlformats.org/drawingml/2006/main">
               <a:ext uri="{FF2B5EF4-FFF2-40B4-BE49-F238E27FC236}">
-                <a16:creationId xmlns:a16="http://schemas.microsoft.com/office/drawing/2014/main" id="{6E6B1B00-2A97-4BED-A8EA-E63BE90E531E}"/>
+                <a16:creationId xmlns:a16="http://schemas.microsoft.com/office/drawing/2014/main" id="{29D88902-2661-405E-A1EB-808CE234DC41}"/>
               </a:ext>
             </a:extLst>
           </p:cNvPr>
@@ -5777,7 +5777,7 @@
           <p:cNvPr id="25" name="">
             <a:extLst xmlns:a="http://schemas.openxmlformats.org/drawingml/2006/main">
               <a:ext uri="{FF2B5EF4-FFF2-40B4-BE49-F238E27FC236}">
-                <a16:creationId xmlns:a16="http://schemas.microsoft.com/office/drawing/2014/main" id="{4A134AC5-38AE-48C4-8589-3F227EC5438B}"/>
+                <a16:creationId xmlns:a16="http://schemas.microsoft.com/office/drawing/2014/main" id="{39F89F74-0F54-467C-8B76-36424155C8CB}"/>
               </a:ext>
             </a:extLst>
           </p:cNvPr>
@@ -5834,7 +5834,7 @@
           <p:cNvPr id="26" name="">
             <a:extLst xmlns:a="http://schemas.openxmlformats.org/drawingml/2006/main">
               <a:ext uri="{FF2B5EF4-FFF2-40B4-BE49-F238E27FC236}">
-                <a16:creationId xmlns:a16="http://schemas.microsoft.com/office/drawing/2014/main" id="{7E9E59AB-27B5-4AC3-8339-D698982FEE9C}"/>
+                <a16:creationId xmlns:a16="http://schemas.microsoft.com/office/drawing/2014/main" id="{3BFC9179-4B00-4E7A-941B-06338097BF95}"/>
               </a:ext>
             </a:extLst>
           </p:cNvPr>
@@ -5891,7 +5891,7 @@
           <p:cNvPr id="27" name="">
             <a:extLst xmlns:a="http://schemas.openxmlformats.org/drawingml/2006/main">
               <a:ext uri="{FF2B5EF4-FFF2-40B4-BE49-F238E27FC236}">
-                <a16:creationId xmlns:a16="http://schemas.microsoft.com/office/drawing/2014/main" id="{16C3243A-F1F5-4D9D-B82D-87562886462A}"/>
+                <a16:creationId xmlns:a16="http://schemas.microsoft.com/office/drawing/2014/main" id="{8F03045C-5D7F-4337-B020-3FDA0D4DD762}"/>
               </a:ext>
             </a:extLst>
           </p:cNvPr>
@@ -5971,7 +5971,7 @@
           <p:cNvPr id="28" name="">
             <a:extLst xmlns:a="http://schemas.openxmlformats.org/drawingml/2006/main">
               <a:ext uri="{FF2B5EF4-FFF2-40B4-BE49-F238E27FC236}">
-                <a16:creationId xmlns:a16="http://schemas.microsoft.com/office/drawing/2014/main" id="{A5F12925-A530-4F5E-9A42-13D64305A30E}"/>
+                <a16:creationId xmlns:a16="http://schemas.microsoft.com/office/drawing/2014/main" id="{EE9AAA10-C156-4E23-97A2-7AAE767F4EF0}"/>
               </a:ext>
             </a:extLst>
           </p:cNvPr>
@@ -6026,7 +6026,7 @@
     </p:spTree>
     <p:extLst>
       <p:ext uri="{BB962C8B-B14F-4D97-AF65-F5344CB8AC3E}">
-        <p14:creationId xmlns:p14="http://schemas.microsoft.com/office/powerpoint/2010/main" val="255724022"/>
+        <p14:creationId xmlns:p14="http://schemas.microsoft.com/office/powerpoint/2010/main" val="1900616803"/>
       </p:ext>
     </p:extLst>
   </p:cSld>
@@ -6057,7 +6057,7 @@
           <p:cNvPr id="23" name="">
             <a:extLst xmlns:a="http://schemas.openxmlformats.org/drawingml/2006/main">
               <a:ext uri="{FF2B5EF4-FFF2-40B4-BE49-F238E27FC236}">
-                <a16:creationId xmlns:a16="http://schemas.microsoft.com/office/drawing/2014/main" id="{F9B6E19A-E171-4171-86C3-673DD1F660F9}"/>
+                <a16:creationId xmlns:a16="http://schemas.microsoft.com/office/drawing/2014/main" id="{B4FB9C82-A91C-439D-A192-C99F10663450}"/>
               </a:ext>
             </a:extLst>
           </p:cNvPr>
@@ -6089,7 +6089,7 @@
           <p:cNvPr id="2" name="">
             <a:extLst xmlns:a="http://schemas.openxmlformats.org/drawingml/2006/main">
               <a:ext uri="{FF2B5EF4-FFF2-40B4-BE49-F238E27FC236}">
-                <a16:creationId xmlns:a16="http://schemas.microsoft.com/office/drawing/2014/main" id="{9EA6B6A3-4E02-4CAC-874A-E8B9382DFB8F}"/>
+                <a16:creationId xmlns:a16="http://schemas.microsoft.com/office/drawing/2014/main" id="{24CFED86-2CFB-4A71-A43C-9F35E547BAA6}"/>
               </a:ext>
             </a:extLst>
           </p:cNvPr>
@@ -6146,7 +6146,7 @@
           <p:cNvPr id="3" name="">
             <a:extLst xmlns:a="http://schemas.openxmlformats.org/drawingml/2006/main">
               <a:ext uri="{FF2B5EF4-FFF2-40B4-BE49-F238E27FC236}">
-                <a16:creationId xmlns:a16="http://schemas.microsoft.com/office/drawing/2014/main" id="{FDAD7852-D8A4-45DD-9D90-385C5AE36CA2}"/>
+                <a16:creationId xmlns:a16="http://schemas.microsoft.com/office/drawing/2014/main" id="{75FA6F96-FF28-4969-8172-78790DDEB93E}"/>
               </a:ext>
             </a:extLst>
           </p:cNvPr>
@@ -6203,7 +6203,7 @@
           <p:cNvPr id="4" name="">
             <a:extLst xmlns:a="http://schemas.openxmlformats.org/drawingml/2006/main">
               <a:ext uri="{FF2B5EF4-FFF2-40B4-BE49-F238E27FC236}">
-                <a16:creationId xmlns:a16="http://schemas.microsoft.com/office/drawing/2014/main" id="{7C7BD494-29A8-4147-8A85-5E12488A18F7}"/>
+                <a16:creationId xmlns:a16="http://schemas.microsoft.com/office/drawing/2014/main" id="{5B193A14-F893-4840-B670-E56E9B0538C0}"/>
               </a:ext>
             </a:extLst>
           </p:cNvPr>
@@ -6238,7 +6238,7 @@
           <p:cNvPr id="5" name="">
             <a:extLst xmlns:a="http://schemas.openxmlformats.org/drawingml/2006/main">
               <a:ext uri="{FF2B5EF4-FFF2-40B4-BE49-F238E27FC236}">
-                <a16:creationId xmlns:a16="http://schemas.microsoft.com/office/drawing/2014/main" id="{3AE26030-6FD4-4EA8-B321-5A86FB062AF7}"/>
+                <a16:creationId xmlns:a16="http://schemas.microsoft.com/office/drawing/2014/main" id="{F269C03D-C395-4958-9BE3-AD24A792ED14}"/>
               </a:ext>
             </a:extLst>
           </p:cNvPr>
@@ -6295,7 +6295,7 @@
           <p:cNvPr id="6" name="">
             <a:extLst xmlns:a="http://schemas.openxmlformats.org/drawingml/2006/main">
               <a:ext uri="{FF2B5EF4-FFF2-40B4-BE49-F238E27FC236}">
-                <a16:creationId xmlns:a16="http://schemas.microsoft.com/office/drawing/2014/main" id="{123C6AF5-DE27-4DEA-AC90-6A155EE6F871}"/>
+                <a16:creationId xmlns:a16="http://schemas.microsoft.com/office/drawing/2014/main" id="{D4063506-0AED-419D-A901-DB54B83F0FB7}"/>
               </a:ext>
             </a:extLst>
           </p:cNvPr>
@@ -6330,7 +6330,7 @@
           <p:cNvPr id="7" name="">
             <a:extLst xmlns:a="http://schemas.openxmlformats.org/drawingml/2006/main">
               <a:ext uri="{FF2B5EF4-FFF2-40B4-BE49-F238E27FC236}">
-                <a16:creationId xmlns:a16="http://schemas.microsoft.com/office/drawing/2014/main" id="{3FAEB01A-D648-4989-94A6-AB3EF974FD22}"/>
+                <a16:creationId xmlns:a16="http://schemas.microsoft.com/office/drawing/2014/main" id="{53E99F43-8098-4E7F-9258-EF478C92441E}"/>
               </a:ext>
             </a:extLst>
           </p:cNvPr>
@@ -6387,7 +6387,7 @@
           <p:cNvPr id="8" name="">
             <a:extLst xmlns:a="http://schemas.openxmlformats.org/drawingml/2006/main">
               <a:ext uri="{FF2B5EF4-FFF2-40B4-BE49-F238E27FC236}">
-                <a16:creationId xmlns:a16="http://schemas.microsoft.com/office/drawing/2014/main" id="{CBD9F802-DF45-40D1-8BAE-C1EE13E02063}"/>
+                <a16:creationId xmlns:a16="http://schemas.microsoft.com/office/drawing/2014/main" id="{B784C510-4C7C-46EC-9FC3-0D555127C2EE}"/>
               </a:ext>
             </a:extLst>
           </p:cNvPr>
@@ -6422,7 +6422,7 @@
           <p:cNvPr id="9" name="">
             <a:extLst xmlns:a="http://schemas.openxmlformats.org/drawingml/2006/main">
               <a:ext uri="{FF2B5EF4-FFF2-40B4-BE49-F238E27FC236}">
-                <a16:creationId xmlns:a16="http://schemas.microsoft.com/office/drawing/2014/main" id="{AEB6F9B4-23E0-4219-9619-FA50A7E313CE}"/>
+                <a16:creationId xmlns:a16="http://schemas.microsoft.com/office/drawing/2014/main" id="{D570F451-EBA6-41FD-9E17-91FA36DCB45C}"/>
               </a:ext>
             </a:extLst>
           </p:cNvPr>
@@ -6479,7 +6479,7 @@
           <p:cNvPr id="10" name="">
             <a:extLst xmlns:a="http://schemas.openxmlformats.org/drawingml/2006/main">
               <a:ext uri="{FF2B5EF4-FFF2-40B4-BE49-F238E27FC236}">
-                <a16:creationId xmlns:a16="http://schemas.microsoft.com/office/drawing/2014/main" id="{A5084387-B693-43AC-82D0-F7159B917F96}"/>
+                <a16:creationId xmlns:a16="http://schemas.microsoft.com/office/drawing/2014/main" id="{DFD354D9-A86B-4E3B-B922-1F0A69C7CEDB}"/>
               </a:ext>
             </a:extLst>
           </p:cNvPr>
@@ -6514,7 +6514,7 @@
           <p:cNvPr id="11" name="">
             <a:extLst xmlns:a="http://schemas.openxmlformats.org/drawingml/2006/main">
               <a:ext uri="{FF2B5EF4-FFF2-40B4-BE49-F238E27FC236}">
-                <a16:creationId xmlns:a16="http://schemas.microsoft.com/office/drawing/2014/main" id="{5F6054AE-A15C-424B-89D8-CF9D9A25916A}"/>
+                <a16:creationId xmlns:a16="http://schemas.microsoft.com/office/drawing/2014/main" id="{5050C26D-738F-4A27-94DD-F24005D246F4}"/>
               </a:ext>
             </a:extLst>
           </p:cNvPr>
@@ -6571,7 +6571,7 @@
           <p:cNvPr id="12" name="">
             <a:extLst xmlns:a="http://schemas.openxmlformats.org/drawingml/2006/main">
               <a:ext uri="{FF2B5EF4-FFF2-40B4-BE49-F238E27FC236}">
-                <a16:creationId xmlns:a16="http://schemas.microsoft.com/office/drawing/2014/main" id="{456E3F7A-06A0-4C0F-BDE5-0C3AA9C20584}"/>
+                <a16:creationId xmlns:a16="http://schemas.microsoft.com/office/drawing/2014/main" id="{99F6E3D5-F344-434A-8EDD-0D39139B43C3}"/>
               </a:ext>
             </a:extLst>
           </p:cNvPr>
@@ -6606,7 +6606,7 @@
           <p:cNvPr id="13" name="">
             <a:extLst xmlns:a="http://schemas.openxmlformats.org/drawingml/2006/main">
               <a:ext uri="{FF2B5EF4-FFF2-40B4-BE49-F238E27FC236}">
-                <a16:creationId xmlns:a16="http://schemas.microsoft.com/office/drawing/2014/main" id="{C3E89B6E-292F-4FC5-9616-C850F6572503}"/>
+                <a16:creationId xmlns:a16="http://schemas.microsoft.com/office/drawing/2014/main" id="{36332A00-AADF-4ACC-AF7B-DE565D33071D}"/>
               </a:ext>
             </a:extLst>
           </p:cNvPr>
@@ -6663,7 +6663,7 @@
           <p:cNvPr id="14" name="">
             <a:extLst xmlns:a="http://schemas.openxmlformats.org/drawingml/2006/main">
               <a:ext uri="{FF2B5EF4-FFF2-40B4-BE49-F238E27FC236}">
-                <a16:creationId xmlns:a16="http://schemas.microsoft.com/office/drawing/2014/main" id="{42FF171F-536A-4865-A00E-AE4942CE2994}"/>
+                <a16:creationId xmlns:a16="http://schemas.microsoft.com/office/drawing/2014/main" id="{2F3E8709-079F-438C-9D24-A0592F07429F}"/>
               </a:ext>
             </a:extLst>
           </p:cNvPr>
@@ -6698,7 +6698,7 @@
           <p:cNvPr id="15" name="">
             <a:extLst xmlns:a="http://schemas.openxmlformats.org/drawingml/2006/main">
               <a:ext uri="{FF2B5EF4-FFF2-40B4-BE49-F238E27FC236}">
-                <a16:creationId xmlns:a16="http://schemas.microsoft.com/office/drawing/2014/main" id="{EC7D994B-AF22-4026-A624-431D136AA9EA}"/>
+                <a16:creationId xmlns:a16="http://schemas.microsoft.com/office/drawing/2014/main" id="{00EFBA5E-F8F4-4F4E-AA69-6029F96A75CF}"/>
               </a:ext>
             </a:extLst>
           </p:cNvPr>
@@ -6755,7 +6755,7 @@
           <p:cNvPr id="16" name="">
             <a:extLst xmlns:a="http://schemas.openxmlformats.org/drawingml/2006/main">
               <a:ext uri="{FF2B5EF4-FFF2-40B4-BE49-F238E27FC236}">
-                <a16:creationId xmlns:a16="http://schemas.microsoft.com/office/drawing/2014/main" id="{3097B939-9A97-41B8-9097-28687F38681C}"/>
+                <a16:creationId xmlns:a16="http://schemas.microsoft.com/office/drawing/2014/main" id="{CF060D72-7D3D-4EA5-BBC0-E764E3C8311B}"/>
               </a:ext>
             </a:extLst>
           </p:cNvPr>
@@ -6786,7 +6786,7 @@
           <p:cNvPr id="17" name="">
             <a:extLst xmlns:a="http://schemas.openxmlformats.org/drawingml/2006/main">
               <a:ext uri="{FF2B5EF4-FFF2-40B4-BE49-F238E27FC236}">
-                <a16:creationId xmlns:a16="http://schemas.microsoft.com/office/drawing/2014/main" id="{B827384F-8130-4CB2-8DE9-A430CC99B0F4}"/>
+                <a16:creationId xmlns:a16="http://schemas.microsoft.com/office/drawing/2014/main" id="{77D7ADD2-A6A1-48AE-A21D-04A7DFF66038}"/>
               </a:ext>
             </a:extLst>
           </p:cNvPr>
@@ -6817,7 +6817,7 @@
           <p:cNvPr id="18" name="">
             <a:extLst xmlns:a="http://schemas.openxmlformats.org/drawingml/2006/main">
               <a:ext uri="{FF2B5EF4-FFF2-40B4-BE49-F238E27FC236}">
-                <a16:creationId xmlns:a16="http://schemas.microsoft.com/office/drawing/2014/main" id="{BB4F1248-CF0B-4903-B797-43319AC2C248}"/>
+                <a16:creationId xmlns:a16="http://schemas.microsoft.com/office/drawing/2014/main" id="{0D9C4123-3BE1-42F4-8FF2-903C559B2BC7}"/>
               </a:ext>
             </a:extLst>
           </p:cNvPr>
@@ -6848,7 +6848,7 @@
           <p:cNvPr id="19" name="">
             <a:extLst xmlns:a="http://schemas.openxmlformats.org/drawingml/2006/main">
               <a:ext uri="{FF2B5EF4-FFF2-40B4-BE49-F238E27FC236}">
-                <a16:creationId xmlns:a16="http://schemas.microsoft.com/office/drawing/2014/main" id="{54CC08BB-15E6-4277-A429-943633621D61}"/>
+                <a16:creationId xmlns:a16="http://schemas.microsoft.com/office/drawing/2014/main" id="{D8E6520F-8E3D-42BF-9C67-B59F71552609}"/>
               </a:ext>
             </a:extLst>
           </p:cNvPr>
@@ -6879,7 +6879,7 @@
           <p:cNvPr id="20" name="">
             <a:extLst xmlns:a="http://schemas.openxmlformats.org/drawingml/2006/main">
               <a:ext uri="{FF2B5EF4-FFF2-40B4-BE49-F238E27FC236}">
-                <a16:creationId xmlns:a16="http://schemas.microsoft.com/office/drawing/2014/main" id="{354D1850-8F4B-4477-9389-763DC9DA42A2}"/>
+                <a16:creationId xmlns:a16="http://schemas.microsoft.com/office/drawing/2014/main" id="{DE380660-8273-4541-A116-540F20BC64D9}"/>
               </a:ext>
             </a:extLst>
           </p:cNvPr>
@@ -6910,7 +6910,7 @@
           <p:cNvPr id="21" name="">
             <a:extLst xmlns:a="http://schemas.openxmlformats.org/drawingml/2006/main">
               <a:ext uri="{FF2B5EF4-FFF2-40B4-BE49-F238E27FC236}">
-                <a16:creationId xmlns:a16="http://schemas.microsoft.com/office/drawing/2014/main" id="{C1F4DACD-4741-4EAD-BD14-C6A642A179D6}"/>
+                <a16:creationId xmlns:a16="http://schemas.microsoft.com/office/drawing/2014/main" id="{57602F43-7C33-4265-88F4-9BDBE36C458A}"/>
               </a:ext>
             </a:extLst>
           </p:cNvPr>
@@ -6941,7 +6941,7 @@
           <p:cNvPr id="22" name="">
             <a:extLst xmlns:a="http://schemas.openxmlformats.org/drawingml/2006/main">
               <a:ext uri="{FF2B5EF4-FFF2-40B4-BE49-F238E27FC236}">
-                <a16:creationId xmlns:a16="http://schemas.microsoft.com/office/drawing/2014/main" id="{E47938FB-61CC-4507-A467-9948165077B7}"/>
+                <a16:creationId xmlns:a16="http://schemas.microsoft.com/office/drawing/2014/main" id="{6522A7AD-E11A-4AA5-9D77-5524B2BB5B78}"/>
               </a:ext>
             </a:extLst>
           </p:cNvPr>
@@ -6996,7 +6996,7 @@
     </p:spTree>
     <p:extLst>
       <p:ext uri="{BB962C8B-B14F-4D97-AF65-F5344CB8AC3E}">
-        <p14:creationId xmlns:p14="http://schemas.microsoft.com/office/powerpoint/2010/main" val="1408632266"/>
+        <p14:creationId xmlns:p14="http://schemas.microsoft.com/office/powerpoint/2010/main" val="1751114729"/>
       </p:ext>
     </p:extLst>
   </p:cSld>
@@ -7027,7 +7027,7 @@
           <p:cNvPr id="12" name="">
             <a:extLst xmlns:a="http://schemas.openxmlformats.org/drawingml/2006/main">
               <a:ext uri="{FF2B5EF4-FFF2-40B4-BE49-F238E27FC236}">
-                <a16:creationId xmlns:a16="http://schemas.microsoft.com/office/drawing/2014/main" id="{8A962B0D-818B-4F68-975C-57DD0045F4E4}"/>
+                <a16:creationId xmlns:a16="http://schemas.microsoft.com/office/drawing/2014/main" id="{169E70A6-FF84-4FA0-BF43-B1F6443FC458}"/>
               </a:ext>
             </a:extLst>
           </p:cNvPr>
@@ -7059,7 +7059,7 @@
           <p:cNvPr id="2" name="">
             <a:extLst xmlns:a="http://schemas.openxmlformats.org/drawingml/2006/main">
               <a:ext uri="{FF2B5EF4-FFF2-40B4-BE49-F238E27FC236}">
-                <a16:creationId xmlns:a16="http://schemas.microsoft.com/office/drawing/2014/main" id="{B0195494-215A-4544-AC9D-0E527CF3B0F4}"/>
+                <a16:creationId xmlns:a16="http://schemas.microsoft.com/office/drawing/2014/main" id="{9BEEC9FF-1795-4B62-8C8F-7273042E0A54}"/>
               </a:ext>
             </a:extLst>
           </p:cNvPr>
@@ -7116,7 +7116,7 @@
           <p:cNvPr id="3" name="">
             <a:extLst xmlns:a="http://schemas.openxmlformats.org/drawingml/2006/main">
               <a:ext uri="{FF2B5EF4-FFF2-40B4-BE49-F238E27FC236}">
-                <a16:creationId xmlns:a16="http://schemas.microsoft.com/office/drawing/2014/main" id="{7C4E0EEA-65CF-4428-B72B-842E5C2D4667}"/>
+                <a16:creationId xmlns:a16="http://schemas.microsoft.com/office/drawing/2014/main" id="{6CBEEA54-1A62-4227-9CB6-B57611A2783C}"/>
               </a:ext>
             </a:extLst>
           </p:cNvPr>
@@ -7173,7 +7173,7 @@
           <p:cNvPr id="4" name="">
             <a:extLst xmlns:a="http://schemas.openxmlformats.org/drawingml/2006/main">
               <a:ext uri="{FF2B5EF4-FFF2-40B4-BE49-F238E27FC236}">
-                <a16:creationId xmlns:a16="http://schemas.microsoft.com/office/drawing/2014/main" id="{A6F47F71-CA0F-4163-91F2-F4F35B4A20B7}"/>
+                <a16:creationId xmlns:a16="http://schemas.microsoft.com/office/drawing/2014/main" id="{FE170D5A-7CDD-41F8-9237-F5AF1B79C454}"/>
               </a:ext>
             </a:extLst>
           </p:cNvPr>
@@ -7230,7 +7230,7 @@
           <p:cNvPr id="5" name="">
             <a:extLst xmlns:a="http://schemas.openxmlformats.org/drawingml/2006/main">
               <a:ext uri="{FF2B5EF4-FFF2-40B4-BE49-F238E27FC236}">
-                <a16:creationId xmlns:a16="http://schemas.microsoft.com/office/drawing/2014/main" id="{459E34AB-EF35-4143-9060-95345525B09B}"/>
+                <a16:creationId xmlns:a16="http://schemas.microsoft.com/office/drawing/2014/main" id="{DF7A459A-ADEF-4065-9C63-45E31951CD0E}"/>
               </a:ext>
             </a:extLst>
           </p:cNvPr>
@@ -7287,7 +7287,7 @@
           <p:cNvPr id="6" name="">
             <a:extLst xmlns:a="http://schemas.openxmlformats.org/drawingml/2006/main">
               <a:ext uri="{FF2B5EF4-FFF2-40B4-BE49-F238E27FC236}">
-                <a16:creationId xmlns:a16="http://schemas.microsoft.com/office/drawing/2014/main" id="{0F6F03AF-7E18-4C3C-8D2A-260092A313B5}"/>
+                <a16:creationId xmlns:a16="http://schemas.microsoft.com/office/drawing/2014/main" id="{CAA5BEE1-AC0D-40A1-AF06-F013340B61B3}"/>
               </a:ext>
             </a:extLst>
           </p:cNvPr>
@@ -7319,7 +7319,7 @@
           <p:cNvPr id="7" name="">
             <a:extLst xmlns:a="http://schemas.openxmlformats.org/drawingml/2006/main">
               <a:ext uri="{FF2B5EF4-FFF2-40B4-BE49-F238E27FC236}">
-                <a16:creationId xmlns:a16="http://schemas.microsoft.com/office/drawing/2014/main" id="{9E1B5490-AB57-49F7-AD2E-84611F682B1C}"/>
+                <a16:creationId xmlns:a16="http://schemas.microsoft.com/office/drawing/2014/main" id="{02BFAD44-AE9C-4C32-AE46-4E81D4AA7776}"/>
               </a:ext>
             </a:extLst>
           </p:cNvPr>
@@ -7351,7 +7351,7 @@
           <p:cNvPr id="8" name="">
             <a:extLst xmlns:a="http://schemas.openxmlformats.org/drawingml/2006/main">
               <a:ext uri="{FF2B5EF4-FFF2-40B4-BE49-F238E27FC236}">
-                <a16:creationId xmlns:a16="http://schemas.microsoft.com/office/drawing/2014/main" id="{97F9DCD7-BDC7-4FBE-B656-790F821C9A48}"/>
+                <a16:creationId xmlns:a16="http://schemas.microsoft.com/office/drawing/2014/main" id="{E2FFCC4D-8AD6-4AA0-8650-57A257BCE28F}"/>
               </a:ext>
             </a:extLst>
           </p:cNvPr>
@@ -7408,7 +7408,7 @@
           <p:cNvPr id="9" name="">
             <a:extLst xmlns:a="http://schemas.openxmlformats.org/drawingml/2006/main">
               <a:ext uri="{FF2B5EF4-FFF2-40B4-BE49-F238E27FC236}">
-                <a16:creationId xmlns:a16="http://schemas.microsoft.com/office/drawing/2014/main" id="{058B3763-F839-4252-8687-31A6C1BA1899}"/>
+                <a16:creationId xmlns:a16="http://schemas.microsoft.com/office/drawing/2014/main" id="{5805BD23-11A0-44B7-AA93-928D70835109}"/>
               </a:ext>
             </a:extLst>
           </p:cNvPr>
@@ -7686,7 +7686,7 @@
           <p:cNvPr id="11" name="">
             <a:extLst xmlns:a="http://schemas.openxmlformats.org/drawingml/2006/main">
               <a:ext uri="{FF2B5EF4-FFF2-40B4-BE49-F238E27FC236}">
-                <a16:creationId xmlns:a16="http://schemas.microsoft.com/office/drawing/2014/main" id="{197C55DA-93C3-4834-81B8-DC49B73E3B73}"/>
+                <a16:creationId xmlns:a16="http://schemas.microsoft.com/office/drawing/2014/main" id="{F94966E7-8AF5-4A4F-BC30-3A2D0CECCA4D}"/>
               </a:ext>
             </a:extLst>
           </p:cNvPr>
@@ -7741,7 +7741,7 @@
     </p:spTree>
     <p:extLst>
       <p:ext uri="{BB962C8B-B14F-4D97-AF65-F5344CB8AC3E}">
-        <p14:creationId xmlns:p14="http://schemas.microsoft.com/office/powerpoint/2010/main" val="1184501300"/>
+        <p14:creationId xmlns:p14="http://schemas.microsoft.com/office/powerpoint/2010/main" val="1506393473"/>
       </p:ext>
     </p:extLst>
   </p:cSld>
@@ -7769,10 +7769,10 @@
       </p:grpSpPr>
       <p:sp>
         <p:nvSpPr>
-          <p:cNvPr id="18" name="">
-            <a:extLst xmlns:a="http://schemas.openxmlformats.org/drawingml/2006/main">
-              <a:ext uri="{FF2B5EF4-FFF2-40B4-BE49-F238E27FC236}">
-                <a16:creationId xmlns:a16="http://schemas.microsoft.com/office/drawing/2014/main" id="{0189197A-C045-4B77-8634-44FBBF820DED}"/>
+          <p:cNvPr id="19" name="">
+            <a:extLst xmlns:a="http://schemas.openxmlformats.org/drawingml/2006/main">
+              <a:ext uri="{FF2B5EF4-FFF2-40B4-BE49-F238E27FC236}">
+                <a16:creationId xmlns:a16="http://schemas.microsoft.com/office/drawing/2014/main" id="{362E8926-6EF4-431B-AB1E-705C3B21D6F8}"/>
               </a:ext>
             </a:extLst>
           </p:cNvPr>
@@ -7804,7 +7804,7 @@
           <p:cNvPr id="2" name="">
             <a:extLst xmlns:a="http://schemas.openxmlformats.org/drawingml/2006/main">
               <a:ext uri="{FF2B5EF4-FFF2-40B4-BE49-F238E27FC236}">
-                <a16:creationId xmlns:a16="http://schemas.microsoft.com/office/drawing/2014/main" id="{1C578257-FBC5-4522-9A6F-06740A1FDD78}"/>
+                <a16:creationId xmlns:a16="http://schemas.microsoft.com/office/drawing/2014/main" id="{3A46D61D-E5E8-4330-8CAE-2AD4B60AB5C9}"/>
               </a:ext>
             </a:extLst>
           </p:cNvPr>
@@ -7861,7 +7861,7 @@
           <p:cNvPr id="3" name="">
             <a:extLst xmlns:a="http://schemas.openxmlformats.org/drawingml/2006/main">
               <a:ext uri="{FF2B5EF4-FFF2-40B4-BE49-F238E27FC236}">
-                <a16:creationId xmlns:a16="http://schemas.microsoft.com/office/drawing/2014/main" id="{C9B15544-B1B1-4972-9495-ECB3A87917FC}"/>
+                <a16:creationId xmlns:a16="http://schemas.microsoft.com/office/drawing/2014/main" id="{69FE208B-E9D6-42C9-9F03-FA15FCA4A29B}"/>
               </a:ext>
             </a:extLst>
           </p:cNvPr>
@@ -7918,7 +7918,7 @@
           <p:cNvPr id="4" name="">
             <a:extLst xmlns:a="http://schemas.openxmlformats.org/drawingml/2006/main">
               <a:ext uri="{FF2B5EF4-FFF2-40B4-BE49-F238E27FC236}">
-                <a16:creationId xmlns:a16="http://schemas.microsoft.com/office/drawing/2014/main" id="{75FF4B67-8BED-40CE-8BF7-B24C74A7EE65}"/>
+                <a16:creationId xmlns:a16="http://schemas.microsoft.com/office/drawing/2014/main" id="{10AF6426-A3DC-4D8D-A303-26EA6FB95331}"/>
               </a:ext>
             </a:extLst>
           </p:cNvPr>
@@ -7975,7 +7975,7 @@
           <p:cNvPr id="5" name="">
             <a:extLst xmlns:a="http://schemas.openxmlformats.org/drawingml/2006/main">
               <a:ext uri="{FF2B5EF4-FFF2-40B4-BE49-F238E27FC236}">
-                <a16:creationId xmlns:a16="http://schemas.microsoft.com/office/drawing/2014/main" id="{48AC5CBB-1949-4E18-A630-522F147D2255}"/>
+                <a16:creationId xmlns:a16="http://schemas.microsoft.com/office/drawing/2014/main" id="{4BC060EB-6376-41FF-9E3B-20260DD85A5C}"/>
               </a:ext>
             </a:extLst>
           </p:cNvPr>
@@ -8032,7 +8032,7 @@
           <p:cNvPr id="6" name="">
             <a:extLst xmlns:a="http://schemas.openxmlformats.org/drawingml/2006/main">
               <a:ext uri="{FF2B5EF4-FFF2-40B4-BE49-F238E27FC236}">
-                <a16:creationId xmlns:a16="http://schemas.microsoft.com/office/drawing/2014/main" id="{E29D2E4A-0FFB-4C30-BF66-F817C3C61E46}"/>
+                <a16:creationId xmlns:a16="http://schemas.microsoft.com/office/drawing/2014/main" id="{D46E7FBB-A73D-46A2-AE53-6FE50CB4DF76}"/>
               </a:ext>
             </a:extLst>
           </p:cNvPr>
@@ -8089,7 +8089,7 @@
           <p:cNvPr id="7" name="">
             <a:extLst xmlns:a="http://schemas.openxmlformats.org/drawingml/2006/main">
               <a:ext uri="{FF2B5EF4-FFF2-40B4-BE49-F238E27FC236}">
-                <a16:creationId xmlns:a16="http://schemas.microsoft.com/office/drawing/2014/main" id="{7433E8D8-7582-4790-8658-8A3474097E42}"/>
+                <a16:creationId xmlns:a16="http://schemas.microsoft.com/office/drawing/2014/main" id="{B5EEBC17-AC39-4381-9E90-195DCAFAA1BA}"/>
               </a:ext>
             </a:extLst>
           </p:cNvPr>
@@ -8136,7 +8136,7 @@
                 <a:ea typeface="Arial"/>
                 <a:cs typeface="Arial"/>
               </a:rPr>
-              <a:t>0.5768</a:t>
+              <a:t>0.5867</a:t>
             </a:r>
           </a:p>
         </p:txBody>
@@ -8146,7 +8146,7 @@
           <p:cNvPr id="8" name="">
             <a:extLst xmlns:a="http://schemas.openxmlformats.org/drawingml/2006/main">
               <a:ext uri="{FF2B5EF4-FFF2-40B4-BE49-F238E27FC236}">
-                <a16:creationId xmlns:a16="http://schemas.microsoft.com/office/drawing/2014/main" id="{36C6117A-0588-491E-8986-0C70DB5D8FBE}"/>
+                <a16:creationId xmlns:a16="http://schemas.microsoft.com/office/drawing/2014/main" id="{4A971773-85FA-4111-AFB4-BD7AF216437B}"/>
               </a:ext>
             </a:extLst>
           </p:cNvPr>
@@ -8203,7 +8203,7 @@
           <p:cNvPr id="9" name="">
             <a:extLst xmlns:a="http://schemas.openxmlformats.org/drawingml/2006/main">
               <a:ext uri="{FF2B5EF4-FFF2-40B4-BE49-F238E27FC236}">
-                <a16:creationId xmlns:a16="http://schemas.microsoft.com/office/drawing/2014/main" id="{E5A67F88-DD08-48B6-98EE-78172CBF234B}"/>
+                <a16:creationId xmlns:a16="http://schemas.microsoft.com/office/drawing/2014/main" id="{EAB8FA50-B279-4AF7-AA5C-98E8A144C6FD}"/>
               </a:ext>
             </a:extLst>
           </p:cNvPr>
@@ -8250,7 +8250,7 @@
                 <a:ea typeface="Arial"/>
                 <a:cs typeface="Arial"/>
               </a:rPr>
-              <a:t>0.5851</a:t>
+              <a:t>0.5884</a:t>
             </a:r>
           </a:p>
         </p:txBody>
@@ -8260,7 +8260,7 @@
           <p:cNvPr id="10" name="">
             <a:extLst xmlns:a="http://schemas.openxmlformats.org/drawingml/2006/main">
               <a:ext uri="{FF2B5EF4-FFF2-40B4-BE49-F238E27FC236}">
-                <a16:creationId xmlns:a16="http://schemas.microsoft.com/office/drawing/2014/main" id="{CD5D9617-04CF-4BD6-A5B9-AF6F482444E9}"/>
+                <a16:creationId xmlns:a16="http://schemas.microsoft.com/office/drawing/2014/main" id="{BDE80E91-61B7-4FAD-B36F-84F7EE173A9E}"/>
               </a:ext>
             </a:extLst>
           </p:cNvPr>
@@ -8317,7 +8317,7 @@
           <p:cNvPr id="11" name="">
             <a:extLst xmlns:a="http://schemas.openxmlformats.org/drawingml/2006/main">
               <a:ext uri="{FF2B5EF4-FFF2-40B4-BE49-F238E27FC236}">
-                <a16:creationId xmlns:a16="http://schemas.microsoft.com/office/drawing/2014/main" id="{B5594CED-0140-40A6-98F1-598B929DB7FF}"/>
+                <a16:creationId xmlns:a16="http://schemas.microsoft.com/office/drawing/2014/main" id="{5ED8C8CF-2CA8-4BEF-9C34-0C9C78F19290}"/>
               </a:ext>
             </a:extLst>
           </p:cNvPr>
@@ -8349,7 +8349,7 @@
           <p:cNvPr id="12" name="">
             <a:extLst xmlns:a="http://schemas.openxmlformats.org/drawingml/2006/main">
               <a:ext uri="{FF2B5EF4-FFF2-40B4-BE49-F238E27FC236}">
-                <a16:creationId xmlns:a16="http://schemas.microsoft.com/office/drawing/2014/main" id="{022711A4-268D-4327-B521-FAE3C976129F}"/>
+                <a16:creationId xmlns:a16="http://schemas.microsoft.com/office/drawing/2014/main" id="{FCAA101D-1B1C-4D61-BA67-D569A1028326}"/>
               </a:ext>
             </a:extLst>
           </p:cNvPr>
@@ -8396,7 +8396,7 @@
                 <a:ea typeface="Arial"/>
                 <a:cs typeface="Arial"/>
               </a:rPr>
-              <a:t>0.7027</a:t>
+              <a:t>0.7072</a:t>
             </a:r>
           </a:p>
         </p:txBody>
@@ -8406,7 +8406,7 @@
           <p:cNvPr id="13" name="">
             <a:extLst xmlns:a="http://schemas.openxmlformats.org/drawingml/2006/main">
               <a:ext uri="{FF2B5EF4-FFF2-40B4-BE49-F238E27FC236}">
-                <a16:creationId xmlns:a16="http://schemas.microsoft.com/office/drawing/2014/main" id="{FB975B24-7DF3-43A0-BD10-CDDEBDE01355}"/>
+                <a16:creationId xmlns:a16="http://schemas.microsoft.com/office/drawing/2014/main" id="{0BA3DAC9-C3CA-4123-AD27-71240C7A34DE}"/>
               </a:ext>
             </a:extLst>
           </p:cNvPr>
@@ -8460,7 +8460,7 @@
       </p:sp>
       <p:graphicFrame>
         <p:nvGraphicFramePr>
-          <p:cNvPr id="31" name="Chart"/>
+          <p:cNvPr id="32" name="Chart"/>
           <p:cNvGraphicFramePr/>
           <p:nvPr/>
         </p:nvGraphicFramePr>
@@ -8470,7 +8470,7 @@
         </p:xfrm>
         <a:graphic xmlns:a="http://schemas.openxmlformats.org/drawingml/2006/main">
           <a:graphicData uri="http://schemas.openxmlformats.org/drawingml/2006/chart">
-            <c:chart xmlns:r="http://schemas.openxmlformats.org/officeDocument/2006/relationships" xmlns:c="http://schemas.openxmlformats.org/drawingml/2006/chart" r:id="R475953ac5de84c76"/>
+            <c:chart xmlns:r="http://schemas.openxmlformats.org/officeDocument/2006/relationships" xmlns:c="http://schemas.openxmlformats.org/drawingml/2006/chart" r:id="Rfa403353a99c4403"/>
           </a:graphicData>
         </a:graphic>
       </p:graphicFrame>
@@ -8479,19 +8479,19 @@
           <p:cNvPr id="15" name="">
             <a:extLst xmlns:a="http://schemas.openxmlformats.org/drawingml/2006/main">
               <a:ext uri="{FF2B5EF4-FFF2-40B4-BE49-F238E27FC236}">
-                <a16:creationId xmlns:a16="http://schemas.microsoft.com/office/drawing/2014/main" id="{FB4A0AD5-0B26-40FA-AEE7-8934DD0CB8C4}"/>
-              </a:ext>
-            </a:extLst>
-          </p:cNvPr>
-          <p:cNvSpPr>
-            <a:spLocks xmlns:a="http://schemas.openxmlformats.org/drawingml/2006/main" noGrp="1"/>
-          </p:cNvSpPr>
-          <p:nvPr/>
-        </p:nvSpPr>
-        <p:spPr>
-          <a:xfrm xmlns:a="http://schemas.openxmlformats.org/drawingml/2006/main">
-            <a:off x="6762750" y="4019550"/>
-            <a:ext cx="3810000" cy="552450"/>
+                <a16:creationId xmlns:a16="http://schemas.microsoft.com/office/drawing/2014/main" id="{988FB5F1-77D2-43BA-81EC-AB56A336FB04}"/>
+              </a:ext>
+            </a:extLst>
+          </p:cNvPr>
+          <p:cNvSpPr>
+            <a:spLocks xmlns:a="http://schemas.openxmlformats.org/drawingml/2006/main" noGrp="1"/>
+          </p:cNvSpPr>
+          <p:nvPr/>
+        </p:nvSpPr>
+        <p:spPr>
+          <a:xfrm xmlns:a="http://schemas.openxmlformats.org/drawingml/2006/main">
+            <a:off x="6762750" y="3905250"/>
+            <a:ext cx="3810000" cy="514350"/>
           </a:xfrm>
           <a:prstGeom xmlns:a="http://schemas.openxmlformats.org/drawingml/2006/main" prst="rect">
             <a:avLst/>
@@ -8508,7 +8508,7 @@
           <a:lstStyle xmlns:a="http://schemas.openxmlformats.org/drawingml/2006/main"/>
           <a:p xmlns:a="http://schemas.openxmlformats.org/drawingml/2006/main">
             <a:pPr algn="l">
-              <a:defRPr sz="1500" b="1" i="0">
+              <a:defRPr sz="1350" b="1" i="0">
                 <a:solidFill>
                   <a:srgbClr val="F6F5ED"/>
                 </a:solidFill>
@@ -8518,7 +8518,7 @@
               </a:defRPr>
             </a:pPr>
             <a:r>
-              <a:rPr sz="1500" b="1" i="0">
+              <a:rPr sz="1350" b="1" i="0">
                 <a:solidFill>
                   <a:srgbClr val="F6F5ED"/>
                 </a:solidFill>
@@ -8526,7 +8526,7 @@
                 <a:ea typeface="Arial"/>
                 <a:cs typeface="Arial"/>
               </a:rPr>
-              <a:t>Прирост BS: +0.2129 IoU гари; +0.2308 mIoU тяжести.</a:t>
+              <a:t>V3 vs V2: +0.0045 Score; BS vs dNBR: +0.2229 IoU, +0.2341 mIoU.</a:t>
             </a:r>
           </a:p>
         </p:txBody>
@@ -8536,36 +8536,36 @@
           <p:cNvPr id="16" name="">
             <a:extLst xmlns:a="http://schemas.openxmlformats.org/drawingml/2006/main">
               <a:ext uri="{FF2B5EF4-FFF2-40B4-BE49-F238E27FC236}">
-                <a16:creationId xmlns:a16="http://schemas.microsoft.com/office/drawing/2014/main" id="{CF322F5C-49BE-4423-9CB5-17C3BF8E655E}"/>
-              </a:ext>
-            </a:extLst>
-          </p:cNvPr>
-          <p:cNvSpPr>
-            <a:spLocks xmlns:a="http://schemas.openxmlformats.org/drawingml/2006/main" noGrp="1"/>
-          </p:cNvSpPr>
-          <p:nvPr/>
-        </p:nvSpPr>
-        <p:spPr>
-          <a:xfrm xmlns:a="http://schemas.openxmlformats.org/drawingml/2006/main">
-            <a:off x="6762750" y="4876800"/>
-            <a:ext cx="3619500" cy="304800"/>
-          </a:xfrm>
-          <a:prstGeom xmlns:a="http://schemas.openxmlformats.org/drawingml/2006/main" prst="rect">
-            <a:avLst/>
-          </a:prstGeom>
-          <a:noFill xmlns:a="http://schemas.openxmlformats.org/drawingml/2006/main"/>
-          <a:ln xmlns:a="http://schemas.openxmlformats.org/drawingml/2006/main" w="0">
-            <a:noFill/>
-          </a:ln>
-        </p:spPr>
-        <p:txBody>
-          <a:bodyPr xmlns:a="http://schemas.openxmlformats.org/drawingml/2006/main">
-            <a:normAutofit fontScale="100000"/>
-          </a:bodyPr>
-          <a:lstStyle xmlns:a="http://schemas.openxmlformats.org/drawingml/2006/main"/>
-          <a:p xmlns:a="http://schemas.openxmlformats.org/drawingml/2006/main">
-            <a:pPr algn="l">
-              <a:defRPr sz="1350" b="1" i="0">
+                <a16:creationId xmlns:a16="http://schemas.microsoft.com/office/drawing/2014/main" id="{D554E602-569F-41A6-980C-9840C42C54E9}"/>
+              </a:ext>
+            </a:extLst>
+          </p:cNvPr>
+          <p:cNvSpPr>
+            <a:spLocks xmlns:a="http://schemas.openxmlformats.org/drawingml/2006/main" noGrp="1"/>
+          </p:cNvSpPr>
+          <p:nvPr/>
+        </p:nvSpPr>
+        <p:spPr>
+          <a:xfrm xmlns:a="http://schemas.openxmlformats.org/drawingml/2006/main">
+            <a:off x="6762750" y="4457700"/>
+            <a:ext cx="3714750" cy="361950"/>
+          </a:xfrm>
+          <a:prstGeom xmlns:a="http://schemas.openxmlformats.org/drawingml/2006/main" prst="rect">
+            <a:avLst/>
+          </a:prstGeom>
+          <a:noFill xmlns:a="http://schemas.openxmlformats.org/drawingml/2006/main"/>
+          <a:ln xmlns:a="http://schemas.openxmlformats.org/drawingml/2006/main" w="0">
+            <a:noFill/>
+          </a:ln>
+        </p:spPr>
+        <p:txBody>
+          <a:bodyPr xmlns:a="http://schemas.openxmlformats.org/drawingml/2006/main">
+            <a:normAutofit fontScale="84524"/>
+          </a:bodyPr>
+          <a:lstStyle xmlns:a="http://schemas.openxmlformats.org/drawingml/2006/main"/>
+          <a:p xmlns:a="http://schemas.openxmlformats.org/drawingml/2006/main">
+            <a:pPr algn="l">
+              <a:defRPr sz="1050" b="0" i="0">
                 <a:solidFill>
                   <a:srgbClr val="A8D6C7"/>
                 </a:solidFill>
@@ -8575,7 +8575,7 @@
               </a:defRPr>
             </a:pPr>
             <a:r>
-              <a:rPr sz="1350" b="1" i="0">
+              <a:rPr sz="1050" b="0" i="0">
                 <a:solidFill>
                   <a:srgbClr val="A8D6C7"/>
                 </a:solidFill>
@@ -8583,7 +8583,7 @@
                 <a:ea typeface="Arial"/>
                 <a:cs typeface="Arial"/>
               </a:rPr>
-              <a:t>CPU offline smoke: 4 сцены, PASS</a:t>
+              <a:t>bootstrap 95%: [−0,0014; +0,0112]; интервал включает 0; прирост условен на выбранных recipes.</a:t>
             </a:r>
           </a:p>
         </p:txBody>
@@ -8593,7 +8593,64 @@
           <p:cNvPr id="17" name="">
             <a:extLst xmlns:a="http://schemas.openxmlformats.org/drawingml/2006/main">
               <a:ext uri="{FF2B5EF4-FFF2-40B4-BE49-F238E27FC236}">
-                <a16:creationId xmlns:a16="http://schemas.microsoft.com/office/drawing/2014/main" id="{7481ABDE-0939-4100-86CD-085FB62928F7}"/>
+                <a16:creationId xmlns:a16="http://schemas.microsoft.com/office/drawing/2014/main" id="{C784565B-F3B0-42AF-95FA-7109C37D0D5C}"/>
+              </a:ext>
+            </a:extLst>
+          </p:cNvPr>
+          <p:cNvSpPr>
+            <a:spLocks xmlns:a="http://schemas.openxmlformats.org/drawingml/2006/main" noGrp="1"/>
+          </p:cNvSpPr>
+          <p:nvPr/>
+        </p:nvSpPr>
+        <p:spPr>
+          <a:xfrm xmlns:a="http://schemas.openxmlformats.org/drawingml/2006/main">
+            <a:off x="6762750" y="4914900"/>
+            <a:ext cx="3714750" cy="514350"/>
+          </a:xfrm>
+          <a:prstGeom xmlns:a="http://schemas.openxmlformats.org/drawingml/2006/main" prst="rect">
+            <a:avLst/>
+          </a:prstGeom>
+          <a:noFill xmlns:a="http://schemas.openxmlformats.org/drawingml/2006/main"/>
+          <a:ln xmlns:a="http://schemas.openxmlformats.org/drawingml/2006/main" w="0">
+            <a:noFill/>
+          </a:ln>
+        </p:spPr>
+        <p:txBody>
+          <a:bodyPr xmlns:a="http://schemas.openxmlformats.org/drawingml/2006/main">
+            <a:normAutofit fontScale="99834"/>
+          </a:bodyPr>
+          <a:lstStyle xmlns:a="http://schemas.openxmlformats.org/drawingml/2006/main"/>
+          <a:p xmlns:a="http://schemas.openxmlformats.org/drawingml/2006/main">
+            <a:pPr algn="l">
+              <a:defRPr sz="1200" b="1" i="0">
+                <a:solidFill>
+                  <a:srgbClr val="A8D6C7"/>
+                </a:solidFill>
+                <a:latin typeface="Arial"/>
+                <a:ea typeface="Arial"/>
+                <a:cs typeface="Arial"/>
+              </a:defRPr>
+            </a:pPr>
+            <a:r>
+              <a:rPr sz="1200" b="1" i="0">
+                <a:solidFill>
+                  <a:srgbClr val="A8D6C7"/>
+                </a:solidFill>
+                <a:latin typeface="Arial"/>
+                <a:ea typeface="Arial"/>
+                <a:cs typeface="Arial"/>
+              </a:rPr>
+              <a:t>V3: CLI 269 чипов / 447 строк — 390,7 с на T4/CUDA; CPU replay 129: Δ=0 во всех 3 checks</a:t>
+            </a:r>
+          </a:p>
+        </p:txBody>
+      </p:sp>
+      <p:sp>
+        <p:nvSpPr>
+          <p:cNvPr id="18" name="">
+            <a:extLst xmlns:a="http://schemas.openxmlformats.org/drawingml/2006/main">
+              <a:ext uri="{FF2B5EF4-FFF2-40B4-BE49-F238E27FC236}">
+                <a16:creationId xmlns:a16="http://schemas.microsoft.com/office/drawing/2014/main" id="{ABDE85B0-C793-405C-AE42-DC215791C437}"/>
               </a:ext>
             </a:extLst>
           </p:cNvPr>
@@ -8640,7 +8697,7 @@
                 <a:ea typeface="Arial"/>
                 <a:cs typeface="Arial"/>
               </a:rPr>
-              <a:t>dNBR comparator не является официальным baseline. CPU replay v2 прошёл на 129 validation-чипах; результаты не оценивают закрытый test.</a:t>
+              <a:t>dNBR comparator не является официальным baseline. CSV validator: EXIT 0; результаты не оценивают закрытый test.</a:t>
             </a:r>
           </a:p>
         </p:txBody>
@@ -8648,7 +8705,7 @@
     </p:spTree>
     <p:extLst>
       <p:ext uri="{BB962C8B-B14F-4D97-AF65-F5344CB8AC3E}">
-        <p14:creationId xmlns:p14="http://schemas.microsoft.com/office/powerpoint/2010/main" val="138696762"/>
+        <p14:creationId xmlns:p14="http://schemas.microsoft.com/office/powerpoint/2010/main" val="556990753"/>
       </p:ext>
     </p:extLst>
   </p:cSld>
@@ -8679,7 +8736,7 @@
           <p:cNvPr id="20" name="">
             <a:extLst xmlns:a="http://schemas.openxmlformats.org/drawingml/2006/main">
               <a:ext uri="{FF2B5EF4-FFF2-40B4-BE49-F238E27FC236}">
-                <a16:creationId xmlns:a16="http://schemas.microsoft.com/office/drawing/2014/main" id="{55A43E8E-23AF-4CEC-B84E-978ABA5BB81D}"/>
+                <a16:creationId xmlns:a16="http://schemas.microsoft.com/office/drawing/2014/main" id="{4CA3E1E5-998F-4A66-A5C1-3CEDC878A656}"/>
               </a:ext>
             </a:extLst>
           </p:cNvPr>
@@ -8711,7 +8768,7 @@
           <p:cNvPr id="2" name="">
             <a:extLst xmlns:a="http://schemas.openxmlformats.org/drawingml/2006/main">
               <a:ext uri="{FF2B5EF4-FFF2-40B4-BE49-F238E27FC236}">
-                <a16:creationId xmlns:a16="http://schemas.microsoft.com/office/drawing/2014/main" id="{4B5752BF-5C40-482C-8586-D4E98FAE318A}"/>
+                <a16:creationId xmlns:a16="http://schemas.microsoft.com/office/drawing/2014/main" id="{7AE8D16F-AEEB-4D1C-8FE8-8D4F270EE924}"/>
               </a:ext>
             </a:extLst>
           </p:cNvPr>
@@ -8768,7 +8825,7 @@
           <p:cNvPr id="3" name="">
             <a:extLst xmlns:a="http://schemas.openxmlformats.org/drawingml/2006/main">
               <a:ext uri="{FF2B5EF4-FFF2-40B4-BE49-F238E27FC236}">
-                <a16:creationId xmlns:a16="http://schemas.microsoft.com/office/drawing/2014/main" id="{21D48DEB-4F7E-48E4-BF25-23649ADC332A}"/>
+                <a16:creationId xmlns:a16="http://schemas.microsoft.com/office/drawing/2014/main" id="{0BF681AD-B07A-495D-BB08-92249BCB5E9E}"/>
               </a:ext>
             </a:extLst>
           </p:cNvPr>
@@ -8825,7 +8882,7 @@
           <p:cNvPr id="4" name="">
             <a:extLst xmlns:a="http://schemas.openxmlformats.org/drawingml/2006/main">
               <a:ext uri="{FF2B5EF4-FFF2-40B4-BE49-F238E27FC236}">
-                <a16:creationId xmlns:a16="http://schemas.microsoft.com/office/drawing/2014/main" id="{AD4ABEBF-3F85-401B-BAF5-E76983EED834}"/>
+                <a16:creationId xmlns:a16="http://schemas.microsoft.com/office/drawing/2014/main" id="{09C9F857-5EC9-4366-818C-D916D734EC96}"/>
               </a:ext>
             </a:extLst>
           </p:cNvPr>
@@ -8882,7 +8939,7 @@
           <p:cNvPr id="5" name="">
             <a:extLst xmlns:a="http://schemas.openxmlformats.org/drawingml/2006/main">
               <a:ext uri="{FF2B5EF4-FFF2-40B4-BE49-F238E27FC236}">
-                <a16:creationId xmlns:a16="http://schemas.microsoft.com/office/drawing/2014/main" id="{E30BFC53-D358-48A5-A23A-951E976E66BF}"/>
+                <a16:creationId xmlns:a16="http://schemas.microsoft.com/office/drawing/2014/main" id="{E369C2E8-8FC3-4597-8E50-F65A541430DE}"/>
               </a:ext>
             </a:extLst>
           </p:cNvPr>
@@ -8914,7 +8971,7 @@
           <p:cNvPr id="6" name="">
             <a:extLst xmlns:a="http://schemas.openxmlformats.org/drawingml/2006/main">
               <a:ext uri="{FF2B5EF4-FFF2-40B4-BE49-F238E27FC236}">
-                <a16:creationId xmlns:a16="http://schemas.microsoft.com/office/drawing/2014/main" id="{B4ADC7D7-081B-4F23-86C8-905A38E54D6D}"/>
+                <a16:creationId xmlns:a16="http://schemas.microsoft.com/office/drawing/2014/main" id="{5830EDEC-FE57-4EFA-80C8-52832E2C6843}"/>
               </a:ext>
             </a:extLst>
           </p:cNvPr>
@@ -8971,7 +9028,7 @@
           <p:cNvPr id="7" name="">
             <a:extLst xmlns:a="http://schemas.openxmlformats.org/drawingml/2006/main">
               <a:ext uri="{FF2B5EF4-FFF2-40B4-BE49-F238E27FC236}">
-                <a16:creationId xmlns:a16="http://schemas.microsoft.com/office/drawing/2014/main" id="{4F9B5B30-424B-4EF6-A55E-718FD34839F8}"/>
+                <a16:creationId xmlns:a16="http://schemas.microsoft.com/office/drawing/2014/main" id="{1C473646-0136-42EB-AE9E-9F5B7360AEEA}"/>
               </a:ext>
             </a:extLst>
           </p:cNvPr>
@@ -9051,7 +9108,7 @@
           <p:cNvPr id="8" name="">
             <a:extLst xmlns:a="http://schemas.openxmlformats.org/drawingml/2006/main">
               <a:ext uri="{FF2B5EF4-FFF2-40B4-BE49-F238E27FC236}">
-                <a16:creationId xmlns:a16="http://schemas.microsoft.com/office/drawing/2014/main" id="{2F2282FC-3862-478D-876A-CF33D6FEA010}"/>
+                <a16:creationId xmlns:a16="http://schemas.microsoft.com/office/drawing/2014/main" id="{C820F056-DA83-44A3-9904-B828ACBF0B09}"/>
               </a:ext>
             </a:extLst>
           </p:cNvPr>
@@ -9083,7 +9140,7 @@
           <p:cNvPr id="9" name="">
             <a:extLst xmlns:a="http://schemas.openxmlformats.org/drawingml/2006/main">
               <a:ext uri="{FF2B5EF4-FFF2-40B4-BE49-F238E27FC236}">
-                <a16:creationId xmlns:a16="http://schemas.microsoft.com/office/drawing/2014/main" id="{E4044FC6-0BCE-4127-BED0-6E4A532C91F1}"/>
+                <a16:creationId xmlns:a16="http://schemas.microsoft.com/office/drawing/2014/main" id="{4A623851-EA56-4A34-8C80-29EB4B332848}"/>
               </a:ext>
             </a:extLst>
           </p:cNvPr>
@@ -9140,7 +9197,7 @@
           <p:cNvPr id="10" name="">
             <a:extLst xmlns:a="http://schemas.openxmlformats.org/drawingml/2006/main">
               <a:ext uri="{FF2B5EF4-FFF2-40B4-BE49-F238E27FC236}">
-                <a16:creationId xmlns:a16="http://schemas.microsoft.com/office/drawing/2014/main" id="{32D1C1E0-9D35-4045-A2DF-F995A2E38816}"/>
+                <a16:creationId xmlns:a16="http://schemas.microsoft.com/office/drawing/2014/main" id="{EF898EAC-9589-4B4F-BE3A-2A3B20F8AA8A}"/>
               </a:ext>
             </a:extLst>
           </p:cNvPr>
@@ -9220,7 +9277,7 @@
           <p:cNvPr id="11" name="">
             <a:extLst xmlns:a="http://schemas.openxmlformats.org/drawingml/2006/main">
               <a:ext uri="{FF2B5EF4-FFF2-40B4-BE49-F238E27FC236}">
-                <a16:creationId xmlns:a16="http://schemas.microsoft.com/office/drawing/2014/main" id="{487C9A3D-A716-4036-ADA2-4CDC5A0627DE}"/>
+                <a16:creationId xmlns:a16="http://schemas.microsoft.com/office/drawing/2014/main" id="{0501D667-6FB8-44EB-B4AD-49D7E5188AB6}"/>
               </a:ext>
             </a:extLst>
           </p:cNvPr>
@@ -9252,7 +9309,7 @@
           <p:cNvPr id="12" name="">
             <a:extLst xmlns:a="http://schemas.openxmlformats.org/drawingml/2006/main">
               <a:ext uri="{FF2B5EF4-FFF2-40B4-BE49-F238E27FC236}">
-                <a16:creationId xmlns:a16="http://schemas.microsoft.com/office/drawing/2014/main" id="{190DF154-77CD-4DA2-8D50-2BCB4C209D7A}"/>
+                <a16:creationId xmlns:a16="http://schemas.microsoft.com/office/drawing/2014/main" id="{E41179C1-FD72-418D-A788-BEECF92697A7}"/>
               </a:ext>
             </a:extLst>
           </p:cNvPr>
@@ -9309,7 +9366,7 @@
           <p:cNvPr id="13" name="">
             <a:extLst xmlns:a="http://schemas.openxmlformats.org/drawingml/2006/main">
               <a:ext uri="{FF2B5EF4-FFF2-40B4-BE49-F238E27FC236}">
-                <a16:creationId xmlns:a16="http://schemas.microsoft.com/office/drawing/2014/main" id="{647841BB-6A7D-4F2D-8BFF-11C6CA604700}"/>
+                <a16:creationId xmlns:a16="http://schemas.microsoft.com/office/drawing/2014/main" id="{D9F6637A-F115-4B05-A835-ECAEA6D91FF8}"/>
               </a:ext>
             </a:extLst>
           </p:cNvPr>
@@ -9389,7 +9446,7 @@
           <p:cNvPr id="14" name="">
             <a:extLst xmlns:a="http://schemas.openxmlformats.org/drawingml/2006/main">
               <a:ext uri="{FF2B5EF4-FFF2-40B4-BE49-F238E27FC236}">
-                <a16:creationId xmlns:a16="http://schemas.microsoft.com/office/drawing/2014/main" id="{BCC13902-36EC-4570-80EA-214C68C6F47E}"/>
+                <a16:creationId xmlns:a16="http://schemas.microsoft.com/office/drawing/2014/main" id="{1639CFBF-EC83-478D-97FE-34E103E45678}"/>
               </a:ext>
             </a:extLst>
           </p:cNvPr>
@@ -9421,7 +9478,7 @@
           <p:cNvPr id="15" name="">
             <a:extLst xmlns:a="http://schemas.openxmlformats.org/drawingml/2006/main">
               <a:ext uri="{FF2B5EF4-FFF2-40B4-BE49-F238E27FC236}">
-                <a16:creationId xmlns:a16="http://schemas.microsoft.com/office/drawing/2014/main" id="{5B9B2E65-93A1-4E75-B9EC-BB2B8551BF9B}"/>
+                <a16:creationId xmlns:a16="http://schemas.microsoft.com/office/drawing/2014/main" id="{E097860B-7729-4200-94C0-EB9033C0E46A}"/>
               </a:ext>
             </a:extLst>
           </p:cNvPr>
@@ -9478,7 +9535,7 @@
           <p:cNvPr id="16" name="">
             <a:extLst xmlns:a="http://schemas.openxmlformats.org/drawingml/2006/main">
               <a:ext uri="{FF2B5EF4-FFF2-40B4-BE49-F238E27FC236}">
-                <a16:creationId xmlns:a16="http://schemas.microsoft.com/office/drawing/2014/main" id="{51CEF4DB-EF9B-49CE-B1D6-5BDA2D870C82}"/>
+                <a16:creationId xmlns:a16="http://schemas.microsoft.com/office/drawing/2014/main" id="{F5FC7D78-56BE-4F31-ABCD-80AC4E4150E0}"/>
               </a:ext>
             </a:extLst>
           </p:cNvPr>
@@ -9562,7 +9619,7 @@
           <p:nvPr/>
         </p:nvPicPr>
         <p:blipFill>
-          <a:blip xmlns:r="http://schemas.openxmlformats.org/officeDocument/2006/relationships" xmlns:a="http://schemas.openxmlformats.org/drawingml/2006/main" r:embed="R51d7a8f2c7f84336"/>
+          <a:blip xmlns:r="http://schemas.openxmlformats.org/officeDocument/2006/relationships" xmlns:a="http://schemas.openxmlformats.org/drawingml/2006/main" r:embed="R7ad4ac4d08d64e84"/>
           <a:stretch xmlns:a="http://schemas.openxmlformats.org/drawingml/2006/main"/>
         </p:blipFill>
         <p:spPr>
@@ -9582,7 +9639,7 @@
           <p:cNvPr id="18" name="">
             <a:extLst xmlns:a="http://schemas.openxmlformats.org/drawingml/2006/main">
               <a:ext uri="{FF2B5EF4-FFF2-40B4-BE49-F238E27FC236}">
-                <a16:creationId xmlns:a16="http://schemas.microsoft.com/office/drawing/2014/main" id="{CB3A72D6-4C82-4EDB-A8A1-14C9FC342B30}"/>
+                <a16:creationId xmlns:a16="http://schemas.microsoft.com/office/drawing/2014/main" id="{F7490F03-F1C0-4C2C-923C-C078F9D7AF9F}"/>
               </a:ext>
             </a:extLst>
           </p:cNvPr>
@@ -9606,7 +9663,7 @@
         </p:spPr>
         <p:txBody>
           <a:bodyPr xmlns:a="http://schemas.openxmlformats.org/drawingml/2006/main">
-            <a:normAutofit fontScale="96568"/>
+            <a:normAutofit fontScale="92854"/>
           </a:bodyPr>
           <a:lstStyle xmlns:a="http://schemas.openxmlformats.org/drawingml/2006/main"/>
           <a:p xmlns:a="http://schemas.openxmlformats.org/drawingml/2006/main">
@@ -9629,7 +9686,7 @@
                 <a:ea typeface="Arial"/>
                 <a:cs typeface="Arial"/>
               </a:rPr>
-              <a:t>Реальный UI: official-ensemble-v2, BS_tr_000159, 938,5 га, покрытие 25,4%. Train/validation-демо, не закрытый test.</a:t>
+              <a:t>Реальный UI V3: official-ensemble-v3, BS_tr_000159, 1 037,3 га, покрытие 25,4%. Train/validation-демо, не закрытый test.</a:t>
             </a:r>
           </a:p>
         </p:txBody>
@@ -9639,7 +9696,7 @@
           <p:cNvPr id="19" name="">
             <a:extLst xmlns:a="http://schemas.openxmlformats.org/drawingml/2006/main">
               <a:ext uri="{FF2B5EF4-FFF2-40B4-BE49-F238E27FC236}">
-                <a16:creationId xmlns:a16="http://schemas.microsoft.com/office/drawing/2014/main" id="{E7F02504-52D8-4078-890F-15CA176DB93A}"/>
+                <a16:creationId xmlns:a16="http://schemas.microsoft.com/office/drawing/2014/main" id="{8CDBB128-76EB-4F24-9E55-50F9298A5304}"/>
               </a:ext>
             </a:extLst>
           </p:cNvPr>
@@ -9694,7 +9751,7 @@
     </p:spTree>
     <p:extLst>
       <p:ext uri="{BB962C8B-B14F-4D97-AF65-F5344CB8AC3E}">
-        <p14:creationId xmlns:p14="http://schemas.microsoft.com/office/powerpoint/2010/main" val="180369288"/>
+        <p14:creationId xmlns:p14="http://schemas.microsoft.com/office/powerpoint/2010/main" val="1001340038"/>
       </p:ext>
     </p:extLst>
   </p:cSld>
@@ -9725,7 +9782,7 @@
           <p:cNvPr id="20" name="">
             <a:extLst xmlns:a="http://schemas.openxmlformats.org/drawingml/2006/main">
               <a:ext uri="{FF2B5EF4-FFF2-40B4-BE49-F238E27FC236}">
-                <a16:creationId xmlns:a16="http://schemas.microsoft.com/office/drawing/2014/main" id="{0A18DFB6-2168-4AA9-8D22-1702D4E5A8F7}"/>
+                <a16:creationId xmlns:a16="http://schemas.microsoft.com/office/drawing/2014/main" id="{D9E0545C-4B6D-4F7C-8D3A-821933B9134B}"/>
               </a:ext>
             </a:extLst>
           </p:cNvPr>
@@ -9757,7 +9814,7 @@
           <p:cNvPr id="2" name="">
             <a:extLst xmlns:a="http://schemas.openxmlformats.org/drawingml/2006/main">
               <a:ext uri="{FF2B5EF4-FFF2-40B4-BE49-F238E27FC236}">
-                <a16:creationId xmlns:a16="http://schemas.microsoft.com/office/drawing/2014/main" id="{7EEBABBF-E921-4965-8014-05EB79BC710B}"/>
+                <a16:creationId xmlns:a16="http://schemas.microsoft.com/office/drawing/2014/main" id="{941FDBED-BDAF-4288-9C7C-B4BF364AAF06}"/>
               </a:ext>
             </a:extLst>
           </p:cNvPr>
@@ -9814,7 +9871,7 @@
           <p:cNvPr id="3" name="">
             <a:extLst xmlns:a="http://schemas.openxmlformats.org/drawingml/2006/main">
               <a:ext uri="{FF2B5EF4-FFF2-40B4-BE49-F238E27FC236}">
-                <a16:creationId xmlns:a16="http://schemas.microsoft.com/office/drawing/2014/main" id="{8B0FA0EE-526B-4092-9E2A-354FBE76BEE9}"/>
+                <a16:creationId xmlns:a16="http://schemas.microsoft.com/office/drawing/2014/main" id="{57AC3E37-686D-4888-B752-6DC939B0E75D}"/>
               </a:ext>
             </a:extLst>
           </p:cNvPr>
@@ -9871,7 +9928,7 @@
           <p:cNvPr id="4" name="">
             <a:extLst xmlns:a="http://schemas.openxmlformats.org/drawingml/2006/main">
               <a:ext uri="{FF2B5EF4-FFF2-40B4-BE49-F238E27FC236}">
-                <a16:creationId xmlns:a16="http://schemas.microsoft.com/office/drawing/2014/main" id="{AD281491-782F-423F-B1DB-7F0577A0631D}"/>
+                <a16:creationId xmlns:a16="http://schemas.microsoft.com/office/drawing/2014/main" id="{8E83C03F-B416-4AAB-97AF-217870E9245D}"/>
               </a:ext>
             </a:extLst>
           </p:cNvPr>
@@ -9906,7 +9963,7 @@
           <p:cNvPr id="5" name="">
             <a:extLst xmlns:a="http://schemas.openxmlformats.org/drawingml/2006/main">
               <a:ext uri="{FF2B5EF4-FFF2-40B4-BE49-F238E27FC236}">
-                <a16:creationId xmlns:a16="http://schemas.microsoft.com/office/drawing/2014/main" id="{2769A16A-B875-44C1-9D18-995B711E1F07}"/>
+                <a16:creationId xmlns:a16="http://schemas.microsoft.com/office/drawing/2014/main" id="{B248981A-B1D0-4333-BFC6-A20EBE6EB31D}"/>
               </a:ext>
             </a:extLst>
           </p:cNvPr>
@@ -9963,7 +10020,7 @@
           <p:cNvPr id="6" name="">
             <a:extLst xmlns:a="http://schemas.openxmlformats.org/drawingml/2006/main">
               <a:ext uri="{FF2B5EF4-FFF2-40B4-BE49-F238E27FC236}">
-                <a16:creationId xmlns:a16="http://schemas.microsoft.com/office/drawing/2014/main" id="{F50CD380-93F6-470E-96F8-F28F9444DEE1}"/>
+                <a16:creationId xmlns:a16="http://schemas.microsoft.com/office/drawing/2014/main" id="{1A32BE3C-A9E7-4A36-A4AC-14BDB42E23B7}"/>
               </a:ext>
             </a:extLst>
           </p:cNvPr>
@@ -10020,7 +10077,7 @@
           <p:cNvPr id="7" name="">
             <a:extLst xmlns:a="http://schemas.openxmlformats.org/drawingml/2006/main">
               <a:ext uri="{FF2B5EF4-FFF2-40B4-BE49-F238E27FC236}">
-                <a16:creationId xmlns:a16="http://schemas.microsoft.com/office/drawing/2014/main" id="{189162E1-70A8-4D42-93CD-8BE70B2F9FB9}"/>
+                <a16:creationId xmlns:a16="http://schemas.microsoft.com/office/drawing/2014/main" id="{798CBB2B-FEDE-4B5E-A606-529081E4FF08}"/>
               </a:ext>
             </a:extLst>
           </p:cNvPr>
@@ -10055,7 +10112,7 @@
           <p:cNvPr id="8" name="">
             <a:extLst xmlns:a="http://schemas.openxmlformats.org/drawingml/2006/main">
               <a:ext uri="{FF2B5EF4-FFF2-40B4-BE49-F238E27FC236}">
-                <a16:creationId xmlns:a16="http://schemas.microsoft.com/office/drawing/2014/main" id="{371ABD8B-0E07-4AB9-9C84-F34F7B8B95A3}"/>
+                <a16:creationId xmlns:a16="http://schemas.microsoft.com/office/drawing/2014/main" id="{57FF7CF3-3CE9-4D14-94CF-0E85F0F0B145}"/>
               </a:ext>
             </a:extLst>
           </p:cNvPr>
@@ -10112,7 +10169,7 @@
           <p:cNvPr id="9" name="">
             <a:extLst xmlns:a="http://schemas.openxmlformats.org/drawingml/2006/main">
               <a:ext uri="{FF2B5EF4-FFF2-40B4-BE49-F238E27FC236}">
-                <a16:creationId xmlns:a16="http://schemas.microsoft.com/office/drawing/2014/main" id="{323D7402-418C-4F81-8DCC-47D298521F6C}"/>
+                <a16:creationId xmlns:a16="http://schemas.microsoft.com/office/drawing/2014/main" id="{D6B5BC4B-E976-47CA-A34A-7C4A4983BC22}"/>
               </a:ext>
             </a:extLst>
           </p:cNvPr>
@@ -10169,7 +10226,7 @@
           <p:cNvPr id="10" name="">
             <a:extLst xmlns:a="http://schemas.openxmlformats.org/drawingml/2006/main">
               <a:ext uri="{FF2B5EF4-FFF2-40B4-BE49-F238E27FC236}">
-                <a16:creationId xmlns:a16="http://schemas.microsoft.com/office/drawing/2014/main" id="{55C88134-89D2-4596-B955-2BF875040EAE}"/>
+                <a16:creationId xmlns:a16="http://schemas.microsoft.com/office/drawing/2014/main" id="{ABD058BD-11D6-482B-A26B-10508DA19A8E}"/>
               </a:ext>
             </a:extLst>
           </p:cNvPr>
@@ -10204,7 +10261,7 @@
           <p:cNvPr id="11" name="">
             <a:extLst xmlns:a="http://schemas.openxmlformats.org/drawingml/2006/main">
               <a:ext uri="{FF2B5EF4-FFF2-40B4-BE49-F238E27FC236}">
-                <a16:creationId xmlns:a16="http://schemas.microsoft.com/office/drawing/2014/main" id="{F1F46842-8F1F-48D0-B7AA-F9E8695977C0}"/>
+                <a16:creationId xmlns:a16="http://schemas.microsoft.com/office/drawing/2014/main" id="{58BE206B-9B0B-4E70-979C-746E855B9D54}"/>
               </a:ext>
             </a:extLst>
           </p:cNvPr>
@@ -10261,7 +10318,7 @@
           <p:cNvPr id="12" name="">
             <a:extLst xmlns:a="http://schemas.openxmlformats.org/drawingml/2006/main">
               <a:ext uri="{FF2B5EF4-FFF2-40B4-BE49-F238E27FC236}">
-                <a16:creationId xmlns:a16="http://schemas.microsoft.com/office/drawing/2014/main" id="{78480D24-E2DA-4B45-9CD5-63D022A50B49}"/>
+                <a16:creationId xmlns:a16="http://schemas.microsoft.com/office/drawing/2014/main" id="{C2EF2D61-5B38-411C-94D8-25B7249BF89A}"/>
               </a:ext>
             </a:extLst>
           </p:cNvPr>
@@ -10318,7 +10375,7 @@
           <p:cNvPr id="13" name="">
             <a:extLst xmlns:a="http://schemas.openxmlformats.org/drawingml/2006/main">
               <a:ext uri="{FF2B5EF4-FFF2-40B4-BE49-F238E27FC236}">
-                <a16:creationId xmlns:a16="http://schemas.microsoft.com/office/drawing/2014/main" id="{7DF94ABF-414C-42EC-9576-E3FE84E6B3E2}"/>
+                <a16:creationId xmlns:a16="http://schemas.microsoft.com/office/drawing/2014/main" id="{85A29DD8-ECFF-46C5-B70A-BF90E620BB2C}"/>
               </a:ext>
             </a:extLst>
           </p:cNvPr>
@@ -10353,7 +10410,7 @@
           <p:cNvPr id="14" name="">
             <a:extLst xmlns:a="http://schemas.openxmlformats.org/drawingml/2006/main">
               <a:ext uri="{FF2B5EF4-FFF2-40B4-BE49-F238E27FC236}">
-                <a16:creationId xmlns:a16="http://schemas.microsoft.com/office/drawing/2014/main" id="{D8407475-E796-45EE-9CFF-2FB60944A1C2}"/>
+                <a16:creationId xmlns:a16="http://schemas.microsoft.com/office/drawing/2014/main" id="{0B4D85C1-BA88-43EE-9C2F-022C64A2C545}"/>
               </a:ext>
             </a:extLst>
           </p:cNvPr>
@@ -10410,7 +10467,7 @@
           <p:cNvPr id="15" name="">
             <a:extLst xmlns:a="http://schemas.openxmlformats.org/drawingml/2006/main">
               <a:ext uri="{FF2B5EF4-FFF2-40B4-BE49-F238E27FC236}">
-                <a16:creationId xmlns:a16="http://schemas.microsoft.com/office/drawing/2014/main" id="{6AFBB701-C60A-4CD2-AE0F-039A0DB84A4A}"/>
+                <a16:creationId xmlns:a16="http://schemas.microsoft.com/office/drawing/2014/main" id="{01774315-DF99-4039-A460-8A9BF34209F3}"/>
               </a:ext>
             </a:extLst>
           </p:cNvPr>
@@ -10467,7 +10524,7 @@
           <p:cNvPr id="16" name="">
             <a:extLst xmlns:a="http://schemas.openxmlformats.org/drawingml/2006/main">
               <a:ext uri="{FF2B5EF4-FFF2-40B4-BE49-F238E27FC236}">
-                <a16:creationId xmlns:a16="http://schemas.microsoft.com/office/drawing/2014/main" id="{228C1F25-22E9-4836-97FF-956A6EEFD7E4}"/>
+                <a16:creationId xmlns:a16="http://schemas.microsoft.com/office/drawing/2014/main" id="{CB8B86E6-7927-4AAC-ADDF-F3B87449B0CF}"/>
               </a:ext>
             </a:extLst>
           </p:cNvPr>
@@ -10502,7 +10559,7 @@
           <p:cNvPr id="17" name="">
             <a:extLst xmlns:a="http://schemas.openxmlformats.org/drawingml/2006/main">
               <a:ext uri="{FF2B5EF4-FFF2-40B4-BE49-F238E27FC236}">
-                <a16:creationId xmlns:a16="http://schemas.microsoft.com/office/drawing/2014/main" id="{6FE523B6-0FE7-4DE4-A7D7-7DB42B63E205}"/>
+                <a16:creationId xmlns:a16="http://schemas.microsoft.com/office/drawing/2014/main" id="{E5310782-319A-4711-81C8-5BAF4C125177}"/>
               </a:ext>
             </a:extLst>
           </p:cNvPr>
@@ -10559,7 +10616,7 @@
           <p:cNvPr id="18" name="">
             <a:extLst xmlns:a="http://schemas.openxmlformats.org/drawingml/2006/main">
               <a:ext uri="{FF2B5EF4-FFF2-40B4-BE49-F238E27FC236}">
-                <a16:creationId xmlns:a16="http://schemas.microsoft.com/office/drawing/2014/main" id="{44C080FD-A173-4B0E-8845-5E564EB54DB4}"/>
+                <a16:creationId xmlns:a16="http://schemas.microsoft.com/office/drawing/2014/main" id="{8D065EEA-904A-4883-8E03-B81BBCAD2600}"/>
               </a:ext>
             </a:extLst>
           </p:cNvPr>
@@ -10616,7 +10673,7 @@
           <p:cNvPr id="19" name="">
             <a:extLst xmlns:a="http://schemas.openxmlformats.org/drawingml/2006/main">
               <a:ext uri="{FF2B5EF4-FFF2-40B4-BE49-F238E27FC236}">
-                <a16:creationId xmlns:a16="http://schemas.microsoft.com/office/drawing/2014/main" id="{A0345FFF-A26F-4054-9306-5B3DC5A5E4A4}"/>
+                <a16:creationId xmlns:a16="http://schemas.microsoft.com/office/drawing/2014/main" id="{7951315F-4FF7-4ACA-8259-8987E3C60439}"/>
               </a:ext>
             </a:extLst>
           </p:cNvPr>
@@ -10640,7 +10697,7 @@
         </p:spPr>
         <p:txBody>
           <a:bodyPr xmlns:a="http://schemas.openxmlformats.org/drawingml/2006/main">
-            <a:normAutofit fontScale="100000"/>
+            <a:normAutofit fontScale="96813"/>
           </a:bodyPr>
           <a:lstStyle xmlns:a="http://schemas.openxmlformats.org/drawingml/2006/main"/>
           <a:p xmlns:a="http://schemas.openxmlformats.org/drawingml/2006/main">
@@ -10663,7 +10720,7 @@
                 <a:ea typeface="Arial"/>
                 <a:cs typeface="Arial"/>
               </a:rPr>
-              <a:t>V2: CLI 447 строк за 540,3 с; CPU replay 129 validation-чипов: PASS. Это не организаторский speed score.</a:t>
+              <a:t>V3: CLI 447 строк за 390,7 с на T4/CUDA; CPU replay 129: Δ=0 во всех 3 checks. Это не организаторский speed score.</a:t>
             </a:r>
           </a:p>
         </p:txBody>
@@ -10671,7 +10728,7 @@
     </p:spTree>
     <p:extLst>
       <p:ext uri="{BB962C8B-B14F-4D97-AF65-F5344CB8AC3E}">
-        <p14:creationId xmlns:p14="http://schemas.microsoft.com/office/powerpoint/2010/main" val="450865968"/>
+        <p14:creationId xmlns:p14="http://schemas.microsoft.com/office/powerpoint/2010/main" val="561722743"/>
       </p:ext>
     </p:extLst>
   </p:cSld>

</xml_diff>